<commit_message>
auto: update poc/workflow_1/align_fail_capture_report.pptx (+1 more)
 poc/workflow_1/align_fail_capture_report.pptx | Bin 33061 -> 36250 bytes
 poc/workflow_1/build_report_pptx.py           | 178 ++++++++++++++++++++++++++
 2 files changed, 178 insertions(+)

Timestamp: 2026-04-27 10:12:06

Co-Authored-By: Claude Opus 4.6 <noreply@anthropic.com>
</commit_message>
<xml_diff>
--- a/poc/workflow_1/align_fail_capture_report.pptx
+++ b/poc/workflow_1/align_fail_capture_report.pptx
@@ -7,6 +7,7 @@
   <p:sldIdLst>
     <p:sldId id="256" r:id="rId7"/>
     <p:sldId id="257" r:id="rId8"/>
+    <p:sldId id="258" r:id="rId9"/>
   </p:sldIdLst>
   <p:sldSz cx="12191695" cy="6858000" type="screen4x3"/>
   <p:notesSz cx="6858000" cy="9144000"/>
@@ -5106,6 +5107,1261 @@
                 <a:latin typeface="Calibri"/>
               </a:rPr>
               <a:t>Status: 사내 Windows 환경에서 동작 검증 중  •  다음 단계: VLM 기반 원인 자동 분석 연계</a:t>
+            </a:r>
+          </a:p>
+        </p:txBody>
+      </p:sp>
+    </p:spTree>
+  </p:cSld>
+  <p:clrMapOvr>
+    <a:masterClrMapping/>
+  </p:clrMapOvr>
+</p:sld>
+</file>
+
+<file path=ppt/slides/slide3.xml><?xml version="1.0" encoding="utf-8"?>
+<p:sld xmlns:a="http://schemas.openxmlformats.org/drawingml/2006/main" xmlns:p="http://schemas.openxmlformats.org/presentationml/2006/main" xmlns:r="http://schemas.openxmlformats.org/officeDocument/2006/relationships">
+  <p:cSld>
+    <p:spTree>
+      <p:nvGrpSpPr>
+        <p:cNvPr id="1" name=""/>
+        <p:cNvGrpSpPr/>
+        <p:nvPr/>
+      </p:nvGrpSpPr>
+      <p:grpSpPr/>
+      <p:sp>
+        <p:nvSpPr>
+          <p:cNvPr id="2" name="Rectangle 1"/>
+          <p:cNvSpPr/>
+          <p:nvPr/>
+        </p:nvSpPr>
+        <p:spPr>
+          <a:xfrm>
+            <a:off x="0" y="0"/>
+            <a:ext cx="12191695" cy="1005840"/>
+          </a:xfrm>
+          <a:prstGeom prst="rect">
+            <a:avLst/>
+          </a:prstGeom>
+          <a:solidFill>
+            <a:srgbClr val="142A55"/>
+          </a:solidFill>
+          <a:ln>
+            <a:noFill/>
+          </a:ln>
+        </p:spPr>
+        <p:style>
+          <a:lnRef idx="1">
+            <a:schemeClr val="accent1"/>
+          </a:lnRef>
+          <a:fillRef idx="3">
+            <a:schemeClr val="accent1"/>
+          </a:fillRef>
+          <a:effectRef idx="2">
+            <a:schemeClr val="accent1"/>
+          </a:effectRef>
+          <a:fontRef idx="minor">
+            <a:schemeClr val="lt1"/>
+          </a:fontRef>
+        </p:style>
+        <p:txBody>
+          <a:bodyPr rtlCol="0" anchor="ctr"/>
+          <a:lstStyle/>
+          <a:p>
+            <a:pPr algn="ctr"/>
+          </a:p>
+        </p:txBody>
+      </p:sp>
+      <p:sp>
+        <p:nvSpPr>
+          <p:cNvPr id="3" name="TextBox 2"/>
+          <p:cNvSpPr txBox="1"/>
+          <p:nvPr/>
+        </p:nvSpPr>
+        <p:spPr>
+          <a:xfrm>
+            <a:off x="365760" y="137160"/>
+            <a:ext cx="11430000" cy="502920"/>
+          </a:xfrm>
+          <a:prstGeom prst="rect">
+            <a:avLst/>
+          </a:prstGeom>
+          <a:noFill/>
+        </p:spPr>
+        <p:txBody>
+          <a:bodyPr wrap="none" lIns="0" rIns="0">
+            <a:spAutoFit/>
+          </a:bodyPr>
+          <a:lstStyle/>
+          <a:p>
+            <a:r>
+              <a:rPr sz="2600" b="1">
+                <a:solidFill>
+                  <a:srgbClr val="FFFFFF"/>
+                </a:solidFill>
+                <a:latin typeface="Calibri"/>
+              </a:rPr>
+              <a:t>다음 난관: 움직이는 SEM 화면에서 Align Key 자동 추적</a:t>
+            </a:r>
+          </a:p>
+        </p:txBody>
+      </p:sp>
+      <p:sp>
+        <p:nvSpPr>
+          <p:cNvPr id="4" name="TextBox 3"/>
+          <p:cNvSpPr txBox="1"/>
+          <p:nvPr/>
+        </p:nvSpPr>
+        <p:spPr>
+          <a:xfrm>
+            <a:off x="365760" y="640080"/>
+            <a:ext cx="11430000" cy="320040"/>
+          </a:xfrm>
+          <a:prstGeom prst="rect">
+            <a:avLst/>
+          </a:prstGeom>
+          <a:noFill/>
+        </p:spPr>
+        <p:txBody>
+          <a:bodyPr wrap="none">
+            <a:spAutoFit/>
+          </a:bodyPr>
+          <a:lstStyle/>
+          <a:p>
+            <a:r>
+              <a:rPr sz="1300" b="0">
+                <a:solidFill>
+                  <a:srgbClr val="CDD7E6"/>
+                </a:solidFill>
+                <a:latin typeface="Calibri"/>
+              </a:rPr>
+              <a:t>VLM 의 무기억(stateless) 한계를 이미지 프로세싱 스코어링으로 보완하는 탐색 루프</a:t>
+            </a:r>
+          </a:p>
+        </p:txBody>
+      </p:sp>
+      <p:sp>
+        <p:nvSpPr>
+          <p:cNvPr id="5" name="Rounded Rectangle 4"/>
+          <p:cNvSpPr/>
+          <p:nvPr/>
+        </p:nvSpPr>
+        <p:spPr>
+          <a:xfrm>
+            <a:off x="365760" y="1280160"/>
+            <a:ext cx="5715000" cy="1828800"/>
+          </a:xfrm>
+          <a:prstGeom prst="roundRect">
+            <a:avLst/>
+          </a:prstGeom>
+          <a:solidFill>
+            <a:srgbClr val="F4F6FA"/>
+          </a:solidFill>
+          <a:ln w="9525">
+            <a:solidFill>
+              <a:srgbClr val="142A55"/>
+            </a:solidFill>
+          </a:ln>
+          <a:effectLst/>
+        </p:spPr>
+        <p:style>
+          <a:lnRef idx="1">
+            <a:schemeClr val="accent1"/>
+          </a:lnRef>
+          <a:fillRef idx="3">
+            <a:schemeClr val="accent1"/>
+          </a:fillRef>
+          <a:effectRef idx="2">
+            <a:schemeClr val="accent1"/>
+          </a:effectRef>
+          <a:fontRef idx="minor">
+            <a:schemeClr val="lt1"/>
+          </a:fontRef>
+        </p:style>
+        <p:txBody>
+          <a:bodyPr rtlCol="0" anchor="ctr"/>
+          <a:lstStyle/>
+          <a:p>
+            <a:pPr algn="ctr"/>
+          </a:p>
+        </p:txBody>
+      </p:sp>
+      <p:sp>
+        <p:nvSpPr>
+          <p:cNvPr id="6" name="TextBox 5"/>
+          <p:cNvSpPr txBox="1"/>
+          <p:nvPr/>
+        </p:nvSpPr>
+        <p:spPr>
+          <a:xfrm>
+            <a:off x="594360" y="1417320"/>
+            <a:ext cx="5257800" cy="411480"/>
+          </a:xfrm>
+          <a:prstGeom prst="rect">
+            <a:avLst/>
+          </a:prstGeom>
+          <a:noFill/>
+        </p:spPr>
+        <p:txBody>
+          <a:bodyPr wrap="none">
+            <a:spAutoFit/>
+          </a:bodyPr>
+          <a:lstStyle/>
+          <a:p>
+            <a:r>
+              <a:rPr sz="1600" b="1">
+                <a:solidFill>
+                  <a:srgbClr val="142A55"/>
+                </a:solidFill>
+                <a:latin typeface="Calibri"/>
+              </a:rPr>
+              <a:t>문제</a:t>
+            </a:r>
+          </a:p>
+        </p:txBody>
+      </p:sp>
+      <p:sp>
+        <p:nvSpPr>
+          <p:cNvPr id="7" name="TextBox 6"/>
+          <p:cNvSpPr txBox="1"/>
+          <p:nvPr/>
+        </p:nvSpPr>
+        <p:spPr>
+          <a:xfrm>
+            <a:off x="594360" y="1874520"/>
+            <a:ext cx="5257800" cy="1097280"/>
+          </a:xfrm>
+          <a:prstGeom prst="rect">
+            <a:avLst/>
+          </a:prstGeom>
+          <a:noFill/>
+        </p:spPr>
+        <p:txBody>
+          <a:bodyPr wrap="square">
+            <a:spAutoFit/>
+          </a:bodyPr>
+          <a:lstStyle/>
+          <a:p>
+            <a:pPr>
+              <a:spcAft>
+                <a:spcPts val="400"/>
+              </a:spcAft>
+            </a:pPr>
+            <a:r>
+              <a:rPr sz="1200" b="0">
+                <a:solidFill>
+                  <a:srgbClr val="222933"/>
+                </a:solidFill>
+                <a:latin typeface="Calibri"/>
+              </a:rPr>
+              <a:t>• SEM Monitor 화면은 스테이지 이동에 따라 실시간으로 바뀜 (정지 이미지가 아님)</a:t>
+            </a:r>
+          </a:p>
+          <a:p>
+            <a:pPr>
+              <a:spcAft>
+                <a:spcPts val="400"/>
+              </a:spcAft>
+            </a:pPr>
+            <a:r>
+              <a:rPr sz="1200" b="0">
+                <a:solidFill>
+                  <a:srgbClr val="222933"/>
+                </a:solidFill>
+                <a:latin typeface="Calibri"/>
+              </a:rPr>
+              <a:t>• 현재 화면이 Recipe 상의 Align Key 와 동일한지를 매 프레임 판단해야 함</a:t>
+            </a:r>
+          </a:p>
+          <a:p>
+            <a:pPr>
+              <a:spcAft>
+                <a:spcPts val="400"/>
+              </a:spcAft>
+            </a:pPr>
+            <a:r>
+              <a:rPr sz="1200" b="0">
+                <a:solidFill>
+                  <a:srgbClr val="222933"/>
+                </a:solidFill>
+                <a:latin typeface="Calibri"/>
+              </a:rPr>
+              <a:t>• VLM 은 호출 간 기억이 없어 '이전에 본 위치/유사도' 를 스스로 추적하지 못함</a:t>
+            </a:r>
+          </a:p>
+          <a:p>
+            <a:pPr>
+              <a:spcAft>
+                <a:spcPts val="400"/>
+              </a:spcAft>
+            </a:pPr>
+            <a:r>
+              <a:rPr sz="1200" b="0">
+                <a:solidFill>
+                  <a:srgbClr val="222933"/>
+                </a:solidFill>
+                <a:latin typeface="Calibri"/>
+              </a:rPr>
+              <a:t>• 단일 VLM 호출만으로는 정량적 매칭 점수를 안정적으로 얻기 어려움</a:t>
+            </a:r>
+          </a:p>
+        </p:txBody>
+      </p:sp>
+      <p:sp>
+        <p:nvSpPr>
+          <p:cNvPr id="8" name="Rounded Rectangle 7"/>
+          <p:cNvSpPr/>
+          <p:nvPr/>
+        </p:nvSpPr>
+        <p:spPr>
+          <a:xfrm>
+            <a:off x="6263640" y="1280160"/>
+            <a:ext cx="5577840" cy="1828800"/>
+          </a:xfrm>
+          <a:prstGeom prst="roundRect">
+            <a:avLst/>
+          </a:prstGeom>
+          <a:solidFill>
+            <a:srgbClr val="F4F6FA"/>
+          </a:solidFill>
+          <a:ln w="9525">
+            <a:solidFill>
+              <a:srgbClr val="142A55"/>
+            </a:solidFill>
+          </a:ln>
+          <a:effectLst/>
+        </p:spPr>
+        <p:style>
+          <a:lnRef idx="1">
+            <a:schemeClr val="accent1"/>
+          </a:lnRef>
+          <a:fillRef idx="3">
+            <a:schemeClr val="accent1"/>
+          </a:fillRef>
+          <a:effectRef idx="2">
+            <a:schemeClr val="accent1"/>
+          </a:effectRef>
+          <a:fontRef idx="minor">
+            <a:schemeClr val="lt1"/>
+          </a:fontRef>
+        </p:style>
+        <p:txBody>
+          <a:bodyPr rtlCol="0" anchor="ctr"/>
+          <a:lstStyle/>
+          <a:p>
+            <a:pPr algn="ctr"/>
+          </a:p>
+        </p:txBody>
+      </p:sp>
+      <p:sp>
+        <p:nvSpPr>
+          <p:cNvPr id="9" name="TextBox 8"/>
+          <p:cNvSpPr txBox="1"/>
+          <p:nvPr/>
+        </p:nvSpPr>
+        <p:spPr>
+          <a:xfrm>
+            <a:off x="6492240" y="1417320"/>
+            <a:ext cx="5120640" cy="411480"/>
+          </a:xfrm>
+          <a:prstGeom prst="rect">
+            <a:avLst/>
+          </a:prstGeom>
+          <a:noFill/>
+        </p:spPr>
+        <p:txBody>
+          <a:bodyPr wrap="none">
+            <a:spAutoFit/>
+          </a:bodyPr>
+          <a:lstStyle/>
+          <a:p>
+            <a:r>
+              <a:rPr sz="1600" b="1">
+                <a:solidFill>
+                  <a:srgbClr val="142A55"/>
+                </a:solidFill>
+                <a:latin typeface="Calibri"/>
+              </a:rPr>
+              <a:t>해결 전략</a:t>
+            </a:r>
+          </a:p>
+        </p:txBody>
+      </p:sp>
+      <p:sp>
+        <p:nvSpPr>
+          <p:cNvPr id="10" name="TextBox 9"/>
+          <p:cNvSpPr txBox="1"/>
+          <p:nvPr/>
+        </p:nvSpPr>
+        <p:spPr>
+          <a:xfrm>
+            <a:off x="6492240" y="1874520"/>
+            <a:ext cx="5120640" cy="1097280"/>
+          </a:xfrm>
+          <a:prstGeom prst="rect">
+            <a:avLst/>
+          </a:prstGeom>
+          <a:noFill/>
+        </p:spPr>
+        <p:txBody>
+          <a:bodyPr wrap="square">
+            <a:spAutoFit/>
+          </a:bodyPr>
+          <a:lstStyle/>
+          <a:p>
+            <a:pPr>
+              <a:spcAft>
+                <a:spcPts val="400"/>
+              </a:spcAft>
+            </a:pPr>
+            <a:r>
+              <a:rPr sz="1200" b="0">
+                <a:solidFill>
+                  <a:srgbClr val="222933"/>
+                </a:solidFill>
+                <a:latin typeface="Calibri"/>
+              </a:rPr>
+              <a:t>• 역할 분리: Image Processing = '얼마나 닮았나' (객관 점수), VLM = '다음에 어디를 볼까' (탐색 정책)</a:t>
+            </a:r>
+          </a:p>
+          <a:p>
+            <a:pPr>
+              <a:spcAft>
+                <a:spcPts val="400"/>
+              </a:spcAft>
+            </a:pPr>
+            <a:r>
+              <a:rPr sz="1200" b="0">
+                <a:solidFill>
+                  <a:srgbClr val="222933"/>
+                </a:solidFill>
+                <a:latin typeface="Calibri"/>
+              </a:rPr>
+              <a:t>• 매 프레임 Recipe Align Key vs SEM 화면을 점수화 → 외부 상태로 보존하여 VLM 의 무기억 보완</a:t>
+            </a:r>
+          </a:p>
+          <a:p>
+            <a:pPr>
+              <a:spcAft>
+                <a:spcPts val="400"/>
+              </a:spcAft>
+            </a:pPr>
+            <a:r>
+              <a:rPr sz="1200" b="0">
+                <a:solidFill>
+                  <a:srgbClr val="222933"/>
+                </a:solidFill>
+                <a:latin typeface="Calibri"/>
+              </a:rPr>
+              <a:t>• 점수가 임계값을 넘을 때까지 VLM 이 스테이지 이동 방향을 제안하며 루프</a:t>
+            </a:r>
+          </a:p>
+          <a:p>
+            <a:pPr>
+              <a:spcAft>
+                <a:spcPts val="400"/>
+              </a:spcAft>
+            </a:pPr>
+            <a:r>
+              <a:rPr sz="1200" b="0">
+                <a:solidFill>
+                  <a:srgbClr val="222933"/>
+                </a:solidFill>
+                <a:latin typeface="Calibri"/>
+              </a:rPr>
+              <a:t>• Best-score 프레임/좌표를 저장하여 실패 시 fallback 으로 활용</a:t>
+            </a:r>
+          </a:p>
+        </p:txBody>
+      </p:sp>
+      <p:sp>
+        <p:nvSpPr>
+          <p:cNvPr id="11" name="Rounded Rectangle 10"/>
+          <p:cNvSpPr/>
+          <p:nvPr/>
+        </p:nvSpPr>
+        <p:spPr>
+          <a:xfrm>
+            <a:off x="365760" y="3383280"/>
+            <a:ext cx="2331720" cy="1417320"/>
+          </a:xfrm>
+          <a:prstGeom prst="roundRect">
+            <a:avLst/>
+          </a:prstGeom>
+          <a:solidFill>
+            <a:srgbClr val="FFFFFF"/>
+          </a:solidFill>
+          <a:ln w="19050">
+            <a:solidFill>
+              <a:srgbClr val="142A55"/>
+            </a:solidFill>
+          </a:ln>
+          <a:effectLst/>
+        </p:spPr>
+        <p:style>
+          <a:lnRef idx="1">
+            <a:schemeClr val="accent1"/>
+          </a:lnRef>
+          <a:fillRef idx="3">
+            <a:schemeClr val="accent1"/>
+          </a:fillRef>
+          <a:effectRef idx="2">
+            <a:schemeClr val="accent1"/>
+          </a:effectRef>
+          <a:fontRef idx="minor">
+            <a:schemeClr val="lt1"/>
+          </a:fontRef>
+        </p:style>
+        <p:txBody>
+          <a:bodyPr rtlCol="0" anchor="ctr"/>
+          <a:lstStyle/>
+          <a:p>
+            <a:pPr algn="ctr"/>
+          </a:p>
+        </p:txBody>
+      </p:sp>
+      <p:sp>
+        <p:nvSpPr>
+          <p:cNvPr id="12" name="TextBox 11"/>
+          <p:cNvSpPr txBox="1"/>
+          <p:nvPr/>
+        </p:nvSpPr>
+        <p:spPr>
+          <a:xfrm>
+            <a:off x="502920" y="3474720"/>
+            <a:ext cx="2057400" cy="320040"/>
+          </a:xfrm>
+          <a:prstGeom prst="rect">
+            <a:avLst/>
+          </a:prstGeom>
+          <a:noFill/>
+        </p:spPr>
+        <p:txBody>
+          <a:bodyPr wrap="none">
+            <a:spAutoFit/>
+          </a:bodyPr>
+          <a:lstStyle/>
+          <a:p>
+            <a:r>
+              <a:rPr sz="1200" b="1">
+                <a:solidFill>
+                  <a:srgbClr val="142A55"/>
+                </a:solidFill>
+                <a:latin typeface="Calibri"/>
+              </a:rPr>
+              <a:t>1. Capture</a:t>
+            </a:r>
+          </a:p>
+        </p:txBody>
+      </p:sp>
+      <p:sp>
+        <p:nvSpPr>
+          <p:cNvPr id="13" name="TextBox 12"/>
+          <p:cNvSpPr txBox="1"/>
+          <p:nvPr/>
+        </p:nvSpPr>
+        <p:spPr>
+          <a:xfrm>
+            <a:off x="502920" y="3840480"/>
+            <a:ext cx="2057400" cy="868680"/>
+          </a:xfrm>
+          <a:prstGeom prst="rect">
+            <a:avLst/>
+          </a:prstGeom>
+          <a:noFill/>
+        </p:spPr>
+        <p:txBody>
+          <a:bodyPr wrap="square">
+            <a:spAutoFit/>
+          </a:bodyPr>
+          <a:lstStyle/>
+          <a:p>
+            <a:r>
+              <a:rPr sz="1000" b="0">
+                <a:solidFill>
+                  <a:srgbClr val="556070"/>
+                </a:solidFill>
+                <a:latin typeface="Calibri"/>
+              </a:rPr>
+              <a:t>SEM Monitor 창에서 현재 프레임 캡처 (CH4 캡처 파이프라인 재사용)</a:t>
+            </a:r>
+          </a:p>
+        </p:txBody>
+      </p:sp>
+      <p:sp>
+        <p:nvSpPr>
+          <p:cNvPr id="14" name="Right Arrow 13"/>
+          <p:cNvSpPr/>
+          <p:nvPr/>
+        </p:nvSpPr>
+        <p:spPr>
+          <a:xfrm>
+            <a:off x="2720340" y="3886200"/>
+            <a:ext cx="274320" cy="411480"/>
+          </a:xfrm>
+          <a:prstGeom prst="rightArrow">
+            <a:avLst/>
+          </a:prstGeom>
+          <a:solidFill>
+            <a:srgbClr val="142A55"/>
+          </a:solidFill>
+          <a:ln>
+            <a:noFill/>
+          </a:ln>
+        </p:spPr>
+        <p:style>
+          <a:lnRef idx="1">
+            <a:schemeClr val="accent1"/>
+          </a:lnRef>
+          <a:fillRef idx="3">
+            <a:schemeClr val="accent1"/>
+          </a:fillRef>
+          <a:effectRef idx="2">
+            <a:schemeClr val="accent1"/>
+          </a:effectRef>
+          <a:fontRef idx="minor">
+            <a:schemeClr val="lt1"/>
+          </a:fontRef>
+        </p:style>
+        <p:txBody>
+          <a:bodyPr rtlCol="0" anchor="ctr"/>
+          <a:lstStyle/>
+          <a:p>
+            <a:pPr algn="ctr"/>
+          </a:p>
+        </p:txBody>
+      </p:sp>
+      <p:sp>
+        <p:nvSpPr>
+          <p:cNvPr id="15" name="Rounded Rectangle 14"/>
+          <p:cNvSpPr/>
+          <p:nvPr/>
+        </p:nvSpPr>
+        <p:spPr>
+          <a:xfrm>
+            <a:off x="3017520" y="3383280"/>
+            <a:ext cx="2331720" cy="1417320"/>
+          </a:xfrm>
+          <a:prstGeom prst="roundRect">
+            <a:avLst/>
+          </a:prstGeom>
+          <a:solidFill>
+            <a:srgbClr val="FFFFFF"/>
+          </a:solidFill>
+          <a:ln w="19050">
+            <a:solidFill>
+              <a:srgbClr val="E86A1F"/>
+            </a:solidFill>
+          </a:ln>
+          <a:effectLst/>
+        </p:spPr>
+        <p:style>
+          <a:lnRef idx="1">
+            <a:schemeClr val="accent1"/>
+          </a:lnRef>
+          <a:fillRef idx="3">
+            <a:schemeClr val="accent1"/>
+          </a:fillRef>
+          <a:effectRef idx="2">
+            <a:schemeClr val="accent1"/>
+          </a:effectRef>
+          <a:fontRef idx="minor">
+            <a:schemeClr val="lt1"/>
+          </a:fontRef>
+        </p:style>
+        <p:txBody>
+          <a:bodyPr rtlCol="0" anchor="ctr"/>
+          <a:lstStyle/>
+          <a:p>
+            <a:pPr algn="ctr"/>
+          </a:p>
+        </p:txBody>
+      </p:sp>
+      <p:sp>
+        <p:nvSpPr>
+          <p:cNvPr id="16" name="TextBox 15"/>
+          <p:cNvSpPr txBox="1"/>
+          <p:nvPr/>
+        </p:nvSpPr>
+        <p:spPr>
+          <a:xfrm>
+            <a:off x="3154680" y="3474720"/>
+            <a:ext cx="2057400" cy="320040"/>
+          </a:xfrm>
+          <a:prstGeom prst="rect">
+            <a:avLst/>
+          </a:prstGeom>
+          <a:noFill/>
+        </p:spPr>
+        <p:txBody>
+          <a:bodyPr wrap="none">
+            <a:spAutoFit/>
+          </a:bodyPr>
+          <a:lstStyle/>
+          <a:p>
+            <a:r>
+              <a:rPr sz="1200" b="1">
+                <a:solidFill>
+                  <a:srgbClr val="E86A1F"/>
+                </a:solidFill>
+                <a:latin typeface="Calibri"/>
+              </a:rPr>
+              <a:t>2. Score (CV)</a:t>
+            </a:r>
+          </a:p>
+        </p:txBody>
+      </p:sp>
+      <p:sp>
+        <p:nvSpPr>
+          <p:cNvPr id="17" name="TextBox 16"/>
+          <p:cNvSpPr txBox="1"/>
+          <p:nvPr/>
+        </p:nvSpPr>
+        <p:spPr>
+          <a:xfrm>
+            <a:off x="3154680" y="3840480"/>
+            <a:ext cx="2057400" cy="868680"/>
+          </a:xfrm>
+          <a:prstGeom prst="rect">
+            <a:avLst/>
+          </a:prstGeom>
+          <a:noFill/>
+        </p:spPr>
+        <p:txBody>
+          <a:bodyPr wrap="square">
+            <a:spAutoFit/>
+          </a:bodyPr>
+          <a:lstStyle/>
+          <a:p>
+            <a:r>
+              <a:rPr sz="1000" b="0">
+                <a:solidFill>
+                  <a:srgbClr val="556070"/>
+                </a:solidFill>
+                <a:latin typeface="Calibri"/>
+              </a:rPr>
+              <a:t>Recipe Align Key 템플릿 vs 현재 프레임 → 유사도 점수
+(Template Match / SSIM / ORB feature)</a:t>
+            </a:r>
+          </a:p>
+        </p:txBody>
+      </p:sp>
+      <p:sp>
+        <p:nvSpPr>
+          <p:cNvPr id="18" name="Right Arrow 17"/>
+          <p:cNvSpPr/>
+          <p:nvPr/>
+        </p:nvSpPr>
+        <p:spPr>
+          <a:xfrm>
+            <a:off x="5372100" y="3886200"/>
+            <a:ext cx="274320" cy="411480"/>
+          </a:xfrm>
+          <a:prstGeom prst="rightArrow">
+            <a:avLst/>
+          </a:prstGeom>
+          <a:solidFill>
+            <a:srgbClr val="142A55"/>
+          </a:solidFill>
+          <a:ln>
+            <a:noFill/>
+          </a:ln>
+        </p:spPr>
+        <p:style>
+          <a:lnRef idx="1">
+            <a:schemeClr val="accent1"/>
+          </a:lnRef>
+          <a:fillRef idx="3">
+            <a:schemeClr val="accent1"/>
+          </a:fillRef>
+          <a:effectRef idx="2">
+            <a:schemeClr val="accent1"/>
+          </a:effectRef>
+          <a:fontRef idx="minor">
+            <a:schemeClr val="lt1"/>
+          </a:fontRef>
+        </p:style>
+        <p:txBody>
+          <a:bodyPr rtlCol="0" anchor="ctr"/>
+          <a:lstStyle/>
+          <a:p>
+            <a:pPr algn="ctr"/>
+          </a:p>
+        </p:txBody>
+      </p:sp>
+      <p:sp>
+        <p:nvSpPr>
+          <p:cNvPr id="19" name="Rounded Rectangle 18"/>
+          <p:cNvSpPr/>
+          <p:nvPr/>
+        </p:nvSpPr>
+        <p:spPr>
+          <a:xfrm>
+            <a:off x="5669280" y="3383280"/>
+            <a:ext cx="2331720" cy="1417320"/>
+          </a:xfrm>
+          <a:prstGeom prst="roundRect">
+            <a:avLst/>
+          </a:prstGeom>
+          <a:solidFill>
+            <a:srgbClr val="FFFFFF"/>
+          </a:solidFill>
+          <a:ln w="19050">
+            <a:solidFill>
+              <a:srgbClr val="142A55"/>
+            </a:solidFill>
+          </a:ln>
+          <a:effectLst/>
+        </p:spPr>
+        <p:style>
+          <a:lnRef idx="1">
+            <a:schemeClr val="accent1"/>
+          </a:lnRef>
+          <a:fillRef idx="3">
+            <a:schemeClr val="accent1"/>
+          </a:fillRef>
+          <a:effectRef idx="2">
+            <a:schemeClr val="accent1"/>
+          </a:effectRef>
+          <a:fontRef idx="minor">
+            <a:schemeClr val="lt1"/>
+          </a:fontRef>
+        </p:style>
+        <p:txBody>
+          <a:bodyPr rtlCol="0" anchor="ctr"/>
+          <a:lstStyle/>
+          <a:p>
+            <a:pPr algn="ctr"/>
+          </a:p>
+        </p:txBody>
+      </p:sp>
+      <p:sp>
+        <p:nvSpPr>
+          <p:cNvPr id="20" name="TextBox 19"/>
+          <p:cNvSpPr txBox="1"/>
+          <p:nvPr/>
+        </p:nvSpPr>
+        <p:spPr>
+          <a:xfrm>
+            <a:off x="5806440" y="3474720"/>
+            <a:ext cx="2057400" cy="320040"/>
+          </a:xfrm>
+          <a:prstGeom prst="rect">
+            <a:avLst/>
+          </a:prstGeom>
+          <a:noFill/>
+        </p:spPr>
+        <p:txBody>
+          <a:bodyPr wrap="none">
+            <a:spAutoFit/>
+          </a:bodyPr>
+          <a:lstStyle/>
+          <a:p>
+            <a:r>
+              <a:rPr sz="1200" b="1">
+                <a:solidFill>
+                  <a:srgbClr val="142A55"/>
+                </a:solidFill>
+                <a:latin typeface="Calibri"/>
+              </a:rPr>
+              <a:t>3. Decide (VLM)</a:t>
+            </a:r>
+          </a:p>
+        </p:txBody>
+      </p:sp>
+      <p:sp>
+        <p:nvSpPr>
+          <p:cNvPr id="21" name="TextBox 20"/>
+          <p:cNvSpPr txBox="1"/>
+          <p:nvPr/>
+        </p:nvSpPr>
+        <p:spPr>
+          <a:xfrm>
+            <a:off x="5806440" y="3840480"/>
+            <a:ext cx="2057400" cy="868680"/>
+          </a:xfrm>
+          <a:prstGeom prst="rect">
+            <a:avLst/>
+          </a:prstGeom>
+          <a:noFill/>
+        </p:spPr>
+        <p:txBody>
+          <a:bodyPr wrap="square">
+            <a:spAutoFit/>
+          </a:bodyPr>
+          <a:lstStyle/>
+          <a:p>
+            <a:r>
+              <a:rPr sz="1000" b="0">
+                <a:solidFill>
+                  <a:srgbClr val="556070"/>
+                </a:solidFill>
+                <a:latin typeface="Calibri"/>
+              </a:rPr>
+              <a:t>점수 + 현재 프레임을 VLM 에 전달 → 일치 여부 판정 +
+다음 이동 방향(↑↓←→/배율) 제안</a:t>
+            </a:r>
+          </a:p>
+        </p:txBody>
+      </p:sp>
+      <p:sp>
+        <p:nvSpPr>
+          <p:cNvPr id="22" name="Right Arrow 21"/>
+          <p:cNvSpPr/>
+          <p:nvPr/>
+        </p:nvSpPr>
+        <p:spPr>
+          <a:xfrm>
+            <a:off x="8023860" y="3886200"/>
+            <a:ext cx="274320" cy="411480"/>
+          </a:xfrm>
+          <a:prstGeom prst="rightArrow">
+            <a:avLst/>
+          </a:prstGeom>
+          <a:solidFill>
+            <a:srgbClr val="142A55"/>
+          </a:solidFill>
+          <a:ln>
+            <a:noFill/>
+          </a:ln>
+        </p:spPr>
+        <p:style>
+          <a:lnRef idx="1">
+            <a:schemeClr val="accent1"/>
+          </a:lnRef>
+          <a:fillRef idx="3">
+            <a:schemeClr val="accent1"/>
+          </a:fillRef>
+          <a:effectRef idx="2">
+            <a:schemeClr val="accent1"/>
+          </a:effectRef>
+          <a:fontRef idx="minor">
+            <a:schemeClr val="lt1"/>
+          </a:fontRef>
+        </p:style>
+        <p:txBody>
+          <a:bodyPr rtlCol="0" anchor="ctr"/>
+          <a:lstStyle/>
+          <a:p>
+            <a:pPr algn="ctr"/>
+          </a:p>
+        </p:txBody>
+      </p:sp>
+      <p:sp>
+        <p:nvSpPr>
+          <p:cNvPr id="23" name="Rounded Rectangle 22"/>
+          <p:cNvSpPr/>
+          <p:nvPr/>
+        </p:nvSpPr>
+        <p:spPr>
+          <a:xfrm>
+            <a:off x="8321040" y="3383280"/>
+            <a:ext cx="2331720" cy="1417320"/>
+          </a:xfrm>
+          <a:prstGeom prst="roundRect">
+            <a:avLst/>
+          </a:prstGeom>
+          <a:solidFill>
+            <a:srgbClr val="FFFFFF"/>
+          </a:solidFill>
+          <a:ln w="19050">
+            <a:solidFill>
+              <a:srgbClr val="E86A1F"/>
+            </a:solidFill>
+          </a:ln>
+          <a:effectLst/>
+        </p:spPr>
+        <p:style>
+          <a:lnRef idx="1">
+            <a:schemeClr val="accent1"/>
+          </a:lnRef>
+          <a:fillRef idx="3">
+            <a:schemeClr val="accent1"/>
+          </a:fillRef>
+          <a:effectRef idx="2">
+            <a:schemeClr val="accent1"/>
+          </a:effectRef>
+          <a:fontRef idx="minor">
+            <a:schemeClr val="lt1"/>
+          </a:fontRef>
+        </p:style>
+        <p:txBody>
+          <a:bodyPr rtlCol="0" anchor="ctr"/>
+          <a:lstStyle/>
+          <a:p>
+            <a:pPr algn="ctr"/>
+          </a:p>
+        </p:txBody>
+      </p:sp>
+      <p:sp>
+        <p:nvSpPr>
+          <p:cNvPr id="24" name="TextBox 23"/>
+          <p:cNvSpPr txBox="1"/>
+          <p:nvPr/>
+        </p:nvSpPr>
+        <p:spPr>
+          <a:xfrm>
+            <a:off x="8458200" y="3474720"/>
+            <a:ext cx="2057400" cy="320040"/>
+          </a:xfrm>
+          <a:prstGeom prst="rect">
+            <a:avLst/>
+          </a:prstGeom>
+          <a:noFill/>
+        </p:spPr>
+        <p:txBody>
+          <a:bodyPr wrap="none">
+            <a:spAutoFit/>
+          </a:bodyPr>
+          <a:lstStyle/>
+          <a:p>
+            <a:r>
+              <a:rPr sz="1200" b="1">
+                <a:solidFill>
+                  <a:srgbClr val="E86A1F"/>
+                </a:solidFill>
+                <a:latin typeface="Calibri"/>
+              </a:rPr>
+              <a:t>4. Move Stage</a:t>
+            </a:r>
+          </a:p>
+        </p:txBody>
+      </p:sp>
+      <p:sp>
+        <p:nvSpPr>
+          <p:cNvPr id="25" name="TextBox 24"/>
+          <p:cNvSpPr txBox="1"/>
+          <p:nvPr/>
+        </p:nvSpPr>
+        <p:spPr>
+          <a:xfrm>
+            <a:off x="8458200" y="3840480"/>
+            <a:ext cx="2057400" cy="868680"/>
+          </a:xfrm>
+          <a:prstGeom prst="rect">
+            <a:avLst/>
+          </a:prstGeom>
+          <a:noFill/>
+        </p:spPr>
+        <p:txBody>
+          <a:bodyPr wrap="square">
+            <a:spAutoFit/>
+          </a:bodyPr>
+          <a:lstStyle/>
+          <a:p>
+            <a:r>
+              <a:rPr sz="1000" b="0">
+                <a:solidFill>
+                  <a:srgbClr val="556070"/>
+                </a:solidFill>
+                <a:latin typeface="Calibri"/>
+              </a:rPr>
+              <a:t>VLM 제안에 따라 SEM 스테이지 이동 명령 →
+임계값 도달까지 1단계로 회귀</a:t>
+            </a:r>
+          </a:p>
+        </p:txBody>
+      </p:sp>
+      <p:sp>
+        <p:nvSpPr>
+          <p:cNvPr id="26" name="TextBox 25"/>
+          <p:cNvSpPr txBox="1"/>
+          <p:nvPr/>
+        </p:nvSpPr>
+        <p:spPr>
+          <a:xfrm>
+            <a:off x="365760" y="4892040"/>
+            <a:ext cx="11475720" cy="320040"/>
+          </a:xfrm>
+          <a:prstGeom prst="rect">
+            <a:avLst/>
+          </a:prstGeom>
+          <a:noFill/>
+        </p:spPr>
+        <p:txBody>
+          <a:bodyPr wrap="none">
+            <a:spAutoFit/>
+          </a:bodyPr>
+          <a:lstStyle/>
+          <a:p>
+            <a:pPr algn="ctr"/>
+            <a:r>
+              <a:rPr sz="1100" b="1">
+                <a:solidFill>
+                  <a:srgbClr val="E86A1F"/>
+                </a:solidFill>
+                <a:latin typeface="Calibri"/>
+              </a:rPr>
+              <a:t>↻  점수 &lt; 임계값이면 1단계로 회귀 (Best-score 갱신하며 수렴까지 반복)</a:t>
+            </a:r>
+          </a:p>
+        </p:txBody>
+      </p:sp>
+      <p:sp>
+        <p:nvSpPr>
+          <p:cNvPr id="27" name="Rounded Rectangle 26"/>
+          <p:cNvSpPr/>
+          <p:nvPr/>
+        </p:nvSpPr>
+        <p:spPr>
+          <a:xfrm>
+            <a:off x="365760" y="5349240"/>
+            <a:ext cx="11475720" cy="1005840"/>
+          </a:xfrm>
+          <a:prstGeom prst="roundRect">
+            <a:avLst/>
+          </a:prstGeom>
+          <a:solidFill>
+            <a:srgbClr val="F4F6FA"/>
+          </a:solidFill>
+          <a:ln w="9525">
+            <a:solidFill>
+              <a:srgbClr val="142A55"/>
+            </a:solidFill>
+          </a:ln>
+          <a:effectLst/>
+        </p:spPr>
+        <p:style>
+          <a:lnRef idx="1">
+            <a:schemeClr val="accent1"/>
+          </a:lnRef>
+          <a:fillRef idx="3">
+            <a:schemeClr val="accent1"/>
+          </a:fillRef>
+          <a:effectRef idx="2">
+            <a:schemeClr val="accent1"/>
+          </a:effectRef>
+          <a:fontRef idx="minor">
+            <a:schemeClr val="lt1"/>
+          </a:fontRef>
+        </p:style>
+        <p:txBody>
+          <a:bodyPr rtlCol="0" anchor="ctr"/>
+          <a:lstStyle/>
+          <a:p>
+            <a:pPr algn="ctr"/>
+          </a:p>
+        </p:txBody>
+      </p:sp>
+      <p:sp>
+        <p:nvSpPr>
+          <p:cNvPr id="28" name="TextBox 27"/>
+          <p:cNvSpPr txBox="1"/>
+          <p:nvPr/>
+        </p:nvSpPr>
+        <p:spPr>
+          <a:xfrm>
+            <a:off x="594360" y="5486400"/>
+            <a:ext cx="11018520" cy="411480"/>
+          </a:xfrm>
+          <a:prstGeom prst="rect">
+            <a:avLst/>
+          </a:prstGeom>
+          <a:noFill/>
+        </p:spPr>
+        <p:txBody>
+          <a:bodyPr wrap="none">
+            <a:spAutoFit/>
+          </a:bodyPr>
+          <a:lstStyle/>
+          <a:p>
+            <a:r>
+              <a:rPr sz="1600" b="1">
+                <a:solidFill>
+                  <a:srgbClr val="142A55"/>
+                </a:solidFill>
+                <a:latin typeface="Calibri"/>
+              </a:rPr>
+              <a:t>기술 스택 &amp; 검증 지표</a:t>
+            </a:r>
+          </a:p>
+        </p:txBody>
+      </p:sp>
+      <p:sp>
+        <p:nvSpPr>
+          <p:cNvPr id="29" name="TextBox 28"/>
+          <p:cNvSpPr txBox="1"/>
+          <p:nvPr/>
+        </p:nvSpPr>
+        <p:spPr>
+          <a:xfrm>
+            <a:off x="594360" y="5943600"/>
+            <a:ext cx="11018520" cy="274320"/>
+          </a:xfrm>
+          <a:prstGeom prst="rect">
+            <a:avLst/>
+          </a:prstGeom>
+          <a:noFill/>
+        </p:spPr>
+        <p:txBody>
+          <a:bodyPr wrap="square">
+            <a:spAutoFit/>
+          </a:bodyPr>
+          <a:lstStyle/>
+          <a:p>
+            <a:pPr>
+              <a:spcAft>
+                <a:spcPts val="400"/>
+              </a:spcAft>
+            </a:pPr>
+            <a:r>
+              <a:rPr sz="1200" b="0">
+                <a:solidFill>
+                  <a:srgbClr val="222933"/>
+                </a:solidFill>
+                <a:latin typeface="Calibri"/>
+              </a:rPr>
+              <a:t>• 이미지 매칭: OpenCV Template Matching · SSIM · ORB/AKAZE feature score 후보 비교</a:t>
+            </a:r>
+          </a:p>
+          <a:p>
+            <a:pPr>
+              <a:spcAft>
+                <a:spcPts val="400"/>
+              </a:spcAft>
+            </a:pPr>
+            <a:r>
+              <a:rPr sz="1200" b="0">
+                <a:solidFill>
+                  <a:srgbClr val="222933"/>
+                </a:solidFill>
+                <a:latin typeface="Calibri"/>
+              </a:rPr>
+              <a:t>• 수렴 지표: 매칭 점수 임계값 도달까지의 평균 루프 횟수 / 실패율 / Best-score fallback 정확도</a:t>
+            </a:r>
+          </a:p>
+        </p:txBody>
+      </p:sp>
+      <p:sp>
+        <p:nvSpPr>
+          <p:cNvPr id="30" name="TextBox 29"/>
+          <p:cNvSpPr txBox="1"/>
+          <p:nvPr/>
+        </p:nvSpPr>
+        <p:spPr>
+          <a:xfrm>
+            <a:off x="365760" y="6446520"/>
+            <a:ext cx="11430000" cy="274320"/>
+          </a:xfrm>
+          <a:prstGeom prst="rect">
+            <a:avLst/>
+          </a:prstGeom>
+          <a:noFill/>
+        </p:spPr>
+        <p:txBody>
+          <a:bodyPr wrap="none">
+            <a:spAutoFit/>
+          </a:bodyPr>
+          <a:lstStyle/>
+          <a:p>
+            <a:r>
+              <a:rPr sz="1000" b="0">
+                <a:solidFill>
+                  <a:srgbClr val="556070"/>
+                </a:solidFill>
+                <a:latin typeface="Calibri"/>
+              </a:rPr>
+              <a:t>Stateless VLM + Stateful CV Score = Convergent Search Loop</a:t>
             </a:r>
           </a:p>
         </p:txBody>

</xml_diff>

<commit_message>
poc/workflow_1: add 2 model-collaboration slides to report
Insert "여러 모델이 협력해서 자동화를 완성한다" overview slide and
"협력 파이프라인: Coarse → Zoom → Fine → Verify" pipeline slide between
existing slide 2 and slide 3 to explain how UI-Venus, MAI-UI,
PaddleOCR-VL, and OpenCV scoring divide responsibilities to achieve
GUI automation.

https://claude.ai/code/session_011LAcHL3SfhmrrBnY2BVwpM
</commit_message>
<xml_diff>
--- a/poc/workflow_1/align_fail_capture_report.pptx
+++ b/poc/workflow_1/align_fail_capture_report.pptx
@@ -8,6 +8,8 @@
     <p:sldId id="256" r:id="rId7"/>
     <p:sldId id="257" r:id="rId8"/>
     <p:sldId id="258" r:id="rId9"/>
+    <p:sldId id="259" r:id="rId10"/>
+    <p:sldId id="260" r:id="rId11"/>
   </p:sldIdLst>
   <p:sldSz cx="12191695" cy="6858000" type="screen4x3"/>
   <p:notesSz cx="6858000" cy="9144000"/>
@@ -5120,6 +5122,2506 @@
 </file>
 
 <file path=ppt/slides/slide3.xml><?xml version="1.0" encoding="utf-8"?>
+<p:sld xmlns:a="http://schemas.openxmlformats.org/drawingml/2006/main" xmlns:p="http://schemas.openxmlformats.org/presentationml/2006/main" xmlns:r="http://schemas.openxmlformats.org/officeDocument/2006/relationships">
+  <p:cSld>
+    <p:spTree>
+      <p:nvGrpSpPr>
+        <p:cNvPr id="1" name=""/>
+        <p:cNvGrpSpPr/>
+        <p:nvPr/>
+      </p:nvGrpSpPr>
+      <p:grpSpPr/>
+      <p:sp>
+        <p:nvSpPr>
+          <p:cNvPr id="2" name="Rectangle 1"/>
+          <p:cNvSpPr/>
+          <p:nvPr/>
+        </p:nvSpPr>
+        <p:spPr>
+          <a:xfrm>
+            <a:off x="0" y="0"/>
+            <a:ext cx="12191695" cy="1005840"/>
+          </a:xfrm>
+          <a:prstGeom prst="rect">
+            <a:avLst/>
+          </a:prstGeom>
+          <a:solidFill>
+            <a:srgbClr val="142A55"/>
+          </a:solidFill>
+          <a:ln>
+            <a:noFill/>
+          </a:ln>
+        </p:spPr>
+        <p:style>
+          <a:lnRef idx="1">
+            <a:schemeClr val="accent1"/>
+          </a:lnRef>
+          <a:fillRef idx="3">
+            <a:schemeClr val="accent1"/>
+          </a:fillRef>
+          <a:effectRef idx="2">
+            <a:schemeClr val="accent1"/>
+          </a:effectRef>
+          <a:fontRef idx="minor">
+            <a:schemeClr val="lt1"/>
+          </a:fontRef>
+        </p:style>
+        <p:txBody>
+          <a:bodyPr rtlCol="0" anchor="ctr"/>
+          <a:lstStyle/>
+          <a:p>
+            <a:pPr algn="ctr"/>
+          </a:p>
+        </p:txBody>
+      </p:sp>
+      <p:sp>
+        <p:nvSpPr>
+          <p:cNvPr id="3" name="TextBox 2"/>
+          <p:cNvSpPr txBox="1"/>
+          <p:nvPr/>
+        </p:nvSpPr>
+        <p:spPr>
+          <a:xfrm>
+            <a:off x="365760" y="137160"/>
+            <a:ext cx="11430000" cy="502920"/>
+          </a:xfrm>
+          <a:prstGeom prst="rect">
+            <a:avLst/>
+          </a:prstGeom>
+          <a:noFill/>
+        </p:spPr>
+        <p:txBody>
+          <a:bodyPr wrap="none" lIns="0" rIns="0">
+            <a:spAutoFit/>
+          </a:bodyPr>
+          <a:lstStyle/>
+          <a:p>
+            <a:r>
+              <a:rPr sz="2600" b="1">
+                <a:solidFill>
+                  <a:srgbClr val="FFFFFF"/>
+                </a:solidFill>
+                <a:latin typeface="Calibri"/>
+              </a:rPr>
+              <a:t>여러 모델이 협력해서 자동화를 완성한다</a:t>
+            </a:r>
+          </a:p>
+        </p:txBody>
+      </p:sp>
+      <p:sp>
+        <p:nvSpPr>
+          <p:cNvPr id="4" name="TextBox 3"/>
+          <p:cNvSpPr txBox="1"/>
+          <p:nvPr/>
+        </p:nvSpPr>
+        <p:spPr>
+          <a:xfrm>
+            <a:off x="365760" y="640080"/>
+            <a:ext cx="11430000" cy="320040"/>
+          </a:xfrm>
+          <a:prstGeom prst="rect">
+            <a:avLst/>
+          </a:prstGeom>
+          <a:noFill/>
+        </p:spPr>
+        <p:txBody>
+          <a:bodyPr wrap="none">
+            <a:spAutoFit/>
+          </a:bodyPr>
+          <a:lstStyle/>
+          <a:p>
+            <a:r>
+              <a:rPr sz="1300" b="0">
+                <a:solidFill>
+                  <a:srgbClr val="CDD7E6"/>
+                </a:solidFill>
+                <a:latin typeface="Calibri"/>
+              </a:rPr>
+              <a:t>단일 모델의 한계를 역할 분담으로 보완 — UI 위치 / 정밀 클릭 / 텍스트 검증 / 정량 점수</a:t>
+            </a:r>
+          </a:p>
+        </p:txBody>
+      </p:sp>
+      <p:sp>
+        <p:nvSpPr>
+          <p:cNvPr id="5" name="Rounded Rectangle 4"/>
+          <p:cNvSpPr/>
+          <p:nvPr/>
+        </p:nvSpPr>
+        <p:spPr>
+          <a:xfrm>
+            <a:off x="365760" y="1280160"/>
+            <a:ext cx="11475720" cy="1417320"/>
+          </a:xfrm>
+          <a:prstGeom prst="roundRect">
+            <a:avLst/>
+          </a:prstGeom>
+          <a:solidFill>
+            <a:srgbClr val="F4F6FA"/>
+          </a:solidFill>
+          <a:ln w="9525">
+            <a:solidFill>
+              <a:srgbClr val="142A55"/>
+            </a:solidFill>
+          </a:ln>
+          <a:effectLst/>
+        </p:spPr>
+        <p:style>
+          <a:lnRef idx="1">
+            <a:schemeClr val="accent1"/>
+          </a:lnRef>
+          <a:fillRef idx="3">
+            <a:schemeClr val="accent1"/>
+          </a:fillRef>
+          <a:effectRef idx="2">
+            <a:schemeClr val="accent1"/>
+          </a:effectRef>
+          <a:fontRef idx="minor">
+            <a:schemeClr val="lt1"/>
+          </a:fontRef>
+        </p:style>
+        <p:txBody>
+          <a:bodyPr rtlCol="0" anchor="ctr"/>
+          <a:lstStyle/>
+          <a:p>
+            <a:pPr algn="ctr"/>
+          </a:p>
+        </p:txBody>
+      </p:sp>
+      <p:sp>
+        <p:nvSpPr>
+          <p:cNvPr id="6" name="TextBox 5"/>
+          <p:cNvSpPr txBox="1"/>
+          <p:nvPr/>
+        </p:nvSpPr>
+        <p:spPr>
+          <a:xfrm>
+            <a:off x="594360" y="1417320"/>
+            <a:ext cx="11018520" cy="411480"/>
+          </a:xfrm>
+          <a:prstGeom prst="rect">
+            <a:avLst/>
+          </a:prstGeom>
+          <a:noFill/>
+        </p:spPr>
+        <p:txBody>
+          <a:bodyPr wrap="none">
+            <a:spAutoFit/>
+          </a:bodyPr>
+          <a:lstStyle/>
+          <a:p>
+            <a:r>
+              <a:rPr sz="1600" b="1">
+                <a:solidFill>
+                  <a:srgbClr val="142A55"/>
+                </a:solidFill>
+                <a:latin typeface="Calibri"/>
+              </a:rPr>
+              <a:t>왜 협력이 필요한가</a:t>
+            </a:r>
+          </a:p>
+        </p:txBody>
+      </p:sp>
+      <p:sp>
+        <p:nvSpPr>
+          <p:cNvPr id="7" name="TextBox 6"/>
+          <p:cNvSpPr txBox="1"/>
+          <p:nvPr/>
+        </p:nvSpPr>
+        <p:spPr>
+          <a:xfrm>
+            <a:off x="594360" y="1874520"/>
+            <a:ext cx="11018520" cy="685800"/>
+          </a:xfrm>
+          <a:prstGeom prst="rect">
+            <a:avLst/>
+          </a:prstGeom>
+          <a:noFill/>
+        </p:spPr>
+        <p:txBody>
+          <a:bodyPr wrap="square">
+            <a:spAutoFit/>
+          </a:bodyPr>
+          <a:lstStyle/>
+          <a:p>
+            <a:pPr>
+              <a:spcAft>
+                <a:spcPts val="400"/>
+              </a:spcAft>
+            </a:pPr>
+            <a:r>
+              <a:rPr sz="1200" b="0">
+                <a:solidFill>
+                  <a:srgbClr val="222933"/>
+                </a:solidFill>
+                <a:latin typeface="Calibri"/>
+              </a:rPr>
+              <a:t>• 단일 VLM 으로 '어디를 클릭할지' 를 한 번에 픽셀 정확도로 맞히기는 어렵다 — 전체 화면에서 좌표를 직접 찍으면 오차가 커서 실제 입력 자동화가 깨진다</a:t>
+            </a:r>
+          </a:p>
+          <a:p>
+            <a:pPr>
+              <a:spcAft>
+                <a:spcPts val="400"/>
+              </a:spcAft>
+            </a:pPr>
+            <a:r>
+              <a:rPr sz="1200" b="0">
+                <a:solidFill>
+                  <a:srgbClr val="222933"/>
+                </a:solidFill>
+                <a:latin typeface="Calibri"/>
+              </a:rPr>
+              <a:t>• VLM 은 호출 간 기억이 없는(stateless) 모델이므로, '직전에 무엇을 했는가' 를 외부에서 보존하고 다음 모델로 넘겨야 한다</a:t>
+            </a:r>
+          </a:p>
+          <a:p>
+            <a:pPr>
+              <a:spcAft>
+                <a:spcPts val="400"/>
+              </a:spcAft>
+            </a:pPr>
+            <a:r>
+              <a:rPr sz="1200" b="0">
+                <a:solidFill>
+                  <a:srgbClr val="222933"/>
+                </a:solidFill>
+                <a:latin typeface="Calibri"/>
+              </a:rPr>
+              <a:t>• 그래서 한 모델이 모든 일을 하는 대신, 각 단계의 강점이 다른 모델을 파이프라인으로 엮어 GUI 자동화를 안정화한다</a:t>
+            </a:r>
+          </a:p>
+        </p:txBody>
+      </p:sp>
+      <p:sp>
+        <p:nvSpPr>
+          <p:cNvPr id="8" name="Rounded Rectangle 7"/>
+          <p:cNvSpPr/>
+          <p:nvPr/>
+        </p:nvSpPr>
+        <p:spPr>
+          <a:xfrm>
+            <a:off x="365760" y="2834640"/>
+            <a:ext cx="2788920" cy="2331720"/>
+          </a:xfrm>
+          <a:prstGeom prst="roundRect">
+            <a:avLst/>
+          </a:prstGeom>
+          <a:solidFill>
+            <a:srgbClr val="FFFFFF"/>
+          </a:solidFill>
+          <a:ln w="19050">
+            <a:solidFill>
+              <a:srgbClr val="142A55"/>
+            </a:solidFill>
+          </a:ln>
+          <a:effectLst/>
+        </p:spPr>
+        <p:style>
+          <a:lnRef idx="1">
+            <a:schemeClr val="accent1"/>
+          </a:lnRef>
+          <a:fillRef idx="3">
+            <a:schemeClr val="accent1"/>
+          </a:fillRef>
+          <a:effectRef idx="2">
+            <a:schemeClr val="accent1"/>
+          </a:effectRef>
+          <a:fontRef idx="minor">
+            <a:schemeClr val="lt1"/>
+          </a:fontRef>
+        </p:style>
+        <p:txBody>
+          <a:bodyPr rtlCol="0" anchor="ctr"/>
+          <a:lstStyle/>
+          <a:p>
+            <a:pPr algn="ctr"/>
+          </a:p>
+        </p:txBody>
+      </p:sp>
+      <p:sp>
+        <p:nvSpPr>
+          <p:cNvPr id="9" name="TextBox 8"/>
+          <p:cNvSpPr txBox="1"/>
+          <p:nvPr/>
+        </p:nvSpPr>
+        <p:spPr>
+          <a:xfrm>
+            <a:off x="548640" y="2944368"/>
+            <a:ext cx="2423160" cy="320040"/>
+          </a:xfrm>
+          <a:prstGeom prst="rect">
+            <a:avLst/>
+          </a:prstGeom>
+          <a:noFill/>
+        </p:spPr>
+        <p:txBody>
+          <a:bodyPr wrap="none">
+            <a:spAutoFit/>
+          </a:bodyPr>
+          <a:lstStyle/>
+          <a:p>
+            <a:r>
+              <a:rPr sz="1100" b="1">
+                <a:solidFill>
+                  <a:srgbClr val="142A55"/>
+                </a:solidFill>
+                <a:latin typeface="Calibri"/>
+              </a:rPr>
+              <a:t>1. Coarse Locator</a:t>
+            </a:r>
+          </a:p>
+        </p:txBody>
+      </p:sp>
+      <p:sp>
+        <p:nvSpPr>
+          <p:cNvPr id="10" name="TextBox 9"/>
+          <p:cNvSpPr txBox="1"/>
+          <p:nvPr/>
+        </p:nvSpPr>
+        <p:spPr>
+          <a:xfrm>
+            <a:off x="548640" y="3246120"/>
+            <a:ext cx="2423160" cy="320040"/>
+          </a:xfrm>
+          <a:prstGeom prst="rect">
+            <a:avLst/>
+          </a:prstGeom>
+          <a:noFill/>
+        </p:spPr>
+        <p:txBody>
+          <a:bodyPr wrap="none">
+            <a:spAutoFit/>
+          </a:bodyPr>
+          <a:lstStyle/>
+          <a:p>
+            <a:r>
+              <a:rPr sz="1400" b="1">
+                <a:solidFill>
+                  <a:srgbClr val="142A55"/>
+                </a:solidFill>
+                <a:latin typeface="Calibri"/>
+              </a:rPr>
+              <a:t>UI-Venus 1.5 (8B)</a:t>
+            </a:r>
+          </a:p>
+        </p:txBody>
+      </p:sp>
+      <p:sp>
+        <p:nvSpPr>
+          <p:cNvPr id="11" name="TextBox 10"/>
+          <p:cNvSpPr txBox="1"/>
+          <p:nvPr/>
+        </p:nvSpPr>
+        <p:spPr>
+          <a:xfrm>
+            <a:off x="548640" y="3611880"/>
+            <a:ext cx="2423160" cy="1417320"/>
+          </a:xfrm>
+          <a:prstGeom prst="rect">
+            <a:avLst/>
+          </a:prstGeom>
+          <a:noFill/>
+        </p:spPr>
+        <p:txBody>
+          <a:bodyPr wrap="square">
+            <a:spAutoFit/>
+          </a:bodyPr>
+          <a:lstStyle/>
+          <a:p>
+            <a:pPr>
+              <a:spcAft>
+                <a:spcPts val="300"/>
+              </a:spcAft>
+            </a:pPr>
+            <a:r>
+              <a:rPr sz="1050" b="0">
+                <a:solidFill>
+                  <a:srgbClr val="222933"/>
+                </a:solidFill>
+                <a:latin typeface="Calibri"/>
+              </a:rPr>
+              <a:t>역할: 전체 화면에서 타겟 UI 요소의 대략적 bbox 를 찾아낸다</a:t>
+            </a:r>
+          </a:p>
+          <a:p>
+            <a:pPr>
+              <a:spcAft>
+                <a:spcPts val="300"/>
+              </a:spcAft>
+            </a:pPr>
+            <a:r>
+              <a:rPr sz="1050" b="0">
+                <a:solidFill>
+                  <a:srgbClr val="556070"/>
+                </a:solidFill>
+                <a:latin typeface="Calibri"/>
+              </a:rPr>
+              <a:t>산출: bbox_1000 좌표 + 타겟 영역 crop 후보</a:t>
+            </a:r>
+          </a:p>
+        </p:txBody>
+      </p:sp>
+      <p:sp>
+        <p:nvSpPr>
+          <p:cNvPr id="12" name="Rounded Rectangle 11"/>
+          <p:cNvSpPr/>
+          <p:nvPr/>
+        </p:nvSpPr>
+        <p:spPr>
+          <a:xfrm>
+            <a:off x="3273552" y="2834640"/>
+            <a:ext cx="2788920" cy="2331720"/>
+          </a:xfrm>
+          <a:prstGeom prst="roundRect">
+            <a:avLst/>
+          </a:prstGeom>
+          <a:solidFill>
+            <a:srgbClr val="FFFFFF"/>
+          </a:solidFill>
+          <a:ln w="19050">
+            <a:solidFill>
+              <a:srgbClr val="E86A1F"/>
+            </a:solidFill>
+          </a:ln>
+          <a:effectLst/>
+        </p:spPr>
+        <p:style>
+          <a:lnRef idx="1">
+            <a:schemeClr val="accent1"/>
+          </a:lnRef>
+          <a:fillRef idx="3">
+            <a:schemeClr val="accent1"/>
+          </a:fillRef>
+          <a:effectRef idx="2">
+            <a:schemeClr val="accent1"/>
+          </a:effectRef>
+          <a:fontRef idx="minor">
+            <a:schemeClr val="lt1"/>
+          </a:fontRef>
+        </p:style>
+        <p:txBody>
+          <a:bodyPr rtlCol="0" anchor="ctr"/>
+          <a:lstStyle/>
+          <a:p>
+            <a:pPr algn="ctr"/>
+          </a:p>
+        </p:txBody>
+      </p:sp>
+      <p:sp>
+        <p:nvSpPr>
+          <p:cNvPr id="13" name="TextBox 12"/>
+          <p:cNvSpPr txBox="1"/>
+          <p:nvPr/>
+        </p:nvSpPr>
+        <p:spPr>
+          <a:xfrm>
+            <a:off x="3456432" y="2944368"/>
+            <a:ext cx="2423160" cy="320040"/>
+          </a:xfrm>
+          <a:prstGeom prst="rect">
+            <a:avLst/>
+          </a:prstGeom>
+          <a:noFill/>
+        </p:spPr>
+        <p:txBody>
+          <a:bodyPr wrap="none">
+            <a:spAutoFit/>
+          </a:bodyPr>
+          <a:lstStyle/>
+          <a:p>
+            <a:r>
+              <a:rPr sz="1100" b="1">
+                <a:solidFill>
+                  <a:srgbClr val="E86A1F"/>
+                </a:solidFill>
+                <a:latin typeface="Calibri"/>
+              </a:rPr>
+              <a:t>2. Fine Refiner</a:t>
+            </a:r>
+          </a:p>
+        </p:txBody>
+      </p:sp>
+      <p:sp>
+        <p:nvSpPr>
+          <p:cNvPr id="14" name="TextBox 13"/>
+          <p:cNvSpPr txBox="1"/>
+          <p:nvPr/>
+        </p:nvSpPr>
+        <p:spPr>
+          <a:xfrm>
+            <a:off x="3456432" y="3246120"/>
+            <a:ext cx="2423160" cy="320040"/>
+          </a:xfrm>
+          <a:prstGeom prst="rect">
+            <a:avLst/>
+          </a:prstGeom>
+          <a:noFill/>
+        </p:spPr>
+        <p:txBody>
+          <a:bodyPr wrap="none">
+            <a:spAutoFit/>
+          </a:bodyPr>
+          <a:lstStyle/>
+          <a:p>
+            <a:r>
+              <a:rPr sz="1400" b="1">
+                <a:solidFill>
+                  <a:srgbClr val="142A55"/>
+                </a:solidFill>
+                <a:latin typeface="Calibri"/>
+              </a:rPr>
+              <a:t>MAI-UI</a:t>
+            </a:r>
+          </a:p>
+        </p:txBody>
+      </p:sp>
+      <p:sp>
+        <p:nvSpPr>
+          <p:cNvPr id="15" name="TextBox 14"/>
+          <p:cNvSpPr txBox="1"/>
+          <p:nvPr/>
+        </p:nvSpPr>
+        <p:spPr>
+          <a:xfrm>
+            <a:off x="3456432" y="3611880"/>
+            <a:ext cx="2423160" cy="1417320"/>
+          </a:xfrm>
+          <a:prstGeom prst="rect">
+            <a:avLst/>
+          </a:prstGeom>
+          <a:noFill/>
+        </p:spPr>
+        <p:txBody>
+          <a:bodyPr wrap="square">
+            <a:spAutoFit/>
+          </a:bodyPr>
+          <a:lstStyle/>
+          <a:p>
+            <a:pPr>
+              <a:spcAft>
+                <a:spcPts val="300"/>
+              </a:spcAft>
+            </a:pPr>
+            <a:r>
+              <a:rPr sz="1050" b="0">
+                <a:solidFill>
+                  <a:srgbClr val="222933"/>
+                </a:solidFill>
+                <a:latin typeface="Calibri"/>
+              </a:rPr>
+              <a:t>역할: Coarse bbox 주변을 확대한 zoom crop 에서 정밀 클릭 좌표를 찍는다</a:t>
+            </a:r>
+          </a:p>
+          <a:p>
+            <a:pPr>
+              <a:spcAft>
+                <a:spcPts val="300"/>
+              </a:spcAft>
+            </a:pPr>
+            <a:r>
+              <a:rPr sz="1050" b="0">
+                <a:solidFill>
+                  <a:srgbClr val="556070"/>
+                </a:solidFill>
+                <a:latin typeface="Calibri"/>
+              </a:rPr>
+              <a:t>산출: (x, y) 픽셀 단위 클릭 포인트</a:t>
+            </a:r>
+          </a:p>
+        </p:txBody>
+      </p:sp>
+      <p:sp>
+        <p:nvSpPr>
+          <p:cNvPr id="16" name="Rounded Rectangle 15"/>
+          <p:cNvSpPr/>
+          <p:nvPr/>
+        </p:nvSpPr>
+        <p:spPr>
+          <a:xfrm>
+            <a:off x="6181344" y="2834640"/>
+            <a:ext cx="2788920" cy="2331720"/>
+          </a:xfrm>
+          <a:prstGeom prst="roundRect">
+            <a:avLst/>
+          </a:prstGeom>
+          <a:solidFill>
+            <a:srgbClr val="FFFFFF"/>
+          </a:solidFill>
+          <a:ln w="19050">
+            <a:solidFill>
+              <a:srgbClr val="142A55"/>
+            </a:solidFill>
+          </a:ln>
+          <a:effectLst/>
+        </p:spPr>
+        <p:style>
+          <a:lnRef idx="1">
+            <a:schemeClr val="accent1"/>
+          </a:lnRef>
+          <a:fillRef idx="3">
+            <a:schemeClr val="accent1"/>
+          </a:fillRef>
+          <a:effectRef idx="2">
+            <a:schemeClr val="accent1"/>
+          </a:effectRef>
+          <a:fontRef idx="minor">
+            <a:schemeClr val="lt1"/>
+          </a:fontRef>
+        </p:style>
+        <p:txBody>
+          <a:bodyPr rtlCol="0" anchor="ctr"/>
+          <a:lstStyle/>
+          <a:p>
+            <a:pPr algn="ctr"/>
+          </a:p>
+        </p:txBody>
+      </p:sp>
+      <p:sp>
+        <p:nvSpPr>
+          <p:cNvPr id="17" name="TextBox 16"/>
+          <p:cNvSpPr txBox="1"/>
+          <p:nvPr/>
+        </p:nvSpPr>
+        <p:spPr>
+          <a:xfrm>
+            <a:off x="6364224" y="2944368"/>
+            <a:ext cx="2423160" cy="320040"/>
+          </a:xfrm>
+          <a:prstGeom prst="rect">
+            <a:avLst/>
+          </a:prstGeom>
+          <a:noFill/>
+        </p:spPr>
+        <p:txBody>
+          <a:bodyPr wrap="none">
+            <a:spAutoFit/>
+          </a:bodyPr>
+          <a:lstStyle/>
+          <a:p>
+            <a:r>
+              <a:rPr sz="1100" b="1">
+                <a:solidFill>
+                  <a:srgbClr val="142A55"/>
+                </a:solidFill>
+                <a:latin typeface="Calibri"/>
+              </a:rPr>
+              <a:t>3. Text Verifier</a:t>
+            </a:r>
+          </a:p>
+        </p:txBody>
+      </p:sp>
+      <p:sp>
+        <p:nvSpPr>
+          <p:cNvPr id="18" name="TextBox 17"/>
+          <p:cNvSpPr txBox="1"/>
+          <p:nvPr/>
+        </p:nvSpPr>
+        <p:spPr>
+          <a:xfrm>
+            <a:off x="6364224" y="3246120"/>
+            <a:ext cx="2423160" cy="320040"/>
+          </a:xfrm>
+          <a:prstGeom prst="rect">
+            <a:avLst/>
+          </a:prstGeom>
+          <a:noFill/>
+        </p:spPr>
+        <p:txBody>
+          <a:bodyPr wrap="none">
+            <a:spAutoFit/>
+          </a:bodyPr>
+          <a:lstStyle/>
+          <a:p>
+            <a:r>
+              <a:rPr sz="1400" b="1">
+                <a:solidFill>
+                  <a:srgbClr val="142A55"/>
+                </a:solidFill>
+                <a:latin typeface="Calibri"/>
+              </a:rPr>
+              <a:t>PaddleOCR-VL 1.5</a:t>
+            </a:r>
+          </a:p>
+        </p:txBody>
+      </p:sp>
+      <p:sp>
+        <p:nvSpPr>
+          <p:cNvPr id="19" name="TextBox 18"/>
+          <p:cNvSpPr txBox="1"/>
+          <p:nvPr/>
+        </p:nvSpPr>
+        <p:spPr>
+          <a:xfrm>
+            <a:off x="6364224" y="3611880"/>
+            <a:ext cx="2423160" cy="1417320"/>
+          </a:xfrm>
+          <a:prstGeom prst="rect">
+            <a:avLst/>
+          </a:prstGeom>
+          <a:noFill/>
+        </p:spPr>
+        <p:txBody>
+          <a:bodyPr wrap="square">
+            <a:spAutoFit/>
+          </a:bodyPr>
+          <a:lstStyle/>
+          <a:p>
+            <a:pPr>
+              <a:spcAft>
+                <a:spcPts val="300"/>
+              </a:spcAft>
+            </a:pPr>
+            <a:r>
+              <a:rPr sz="1050" b="0">
+                <a:solidFill>
+                  <a:srgbClr val="222933"/>
+                </a:solidFill>
+                <a:latin typeface="Calibri"/>
+              </a:rPr>
+              <a:t>역할: 입력 후 화면의 텍스트를 OCR 로 읽어 의도한 값이 들어갔는지 검증한다</a:t>
+            </a:r>
+          </a:p>
+          <a:p>
+            <a:pPr>
+              <a:spcAft>
+                <a:spcPts val="300"/>
+              </a:spcAft>
+            </a:pPr>
+            <a:r>
+              <a:rPr sz="1050" b="0">
+                <a:solidFill>
+                  <a:srgbClr val="556070"/>
+                </a:solidFill>
+                <a:latin typeface="Calibri"/>
+              </a:rPr>
+              <a:t>산출: 필드별 OCR 결과 + 일치 여부</a:t>
+            </a:r>
+          </a:p>
+        </p:txBody>
+      </p:sp>
+      <p:sp>
+        <p:nvSpPr>
+          <p:cNvPr id="20" name="Rounded Rectangle 19"/>
+          <p:cNvSpPr/>
+          <p:nvPr/>
+        </p:nvSpPr>
+        <p:spPr>
+          <a:xfrm>
+            <a:off x="9089136" y="2834640"/>
+            <a:ext cx="2788920" cy="2331720"/>
+          </a:xfrm>
+          <a:prstGeom prst="roundRect">
+            <a:avLst/>
+          </a:prstGeom>
+          <a:solidFill>
+            <a:srgbClr val="FFFFFF"/>
+          </a:solidFill>
+          <a:ln w="19050">
+            <a:solidFill>
+              <a:srgbClr val="E86A1F"/>
+            </a:solidFill>
+          </a:ln>
+          <a:effectLst/>
+        </p:spPr>
+        <p:style>
+          <a:lnRef idx="1">
+            <a:schemeClr val="accent1"/>
+          </a:lnRef>
+          <a:fillRef idx="3">
+            <a:schemeClr val="accent1"/>
+          </a:fillRef>
+          <a:effectRef idx="2">
+            <a:schemeClr val="accent1"/>
+          </a:effectRef>
+          <a:fontRef idx="minor">
+            <a:schemeClr val="lt1"/>
+          </a:fontRef>
+        </p:style>
+        <p:txBody>
+          <a:bodyPr rtlCol="0" anchor="ctr"/>
+          <a:lstStyle/>
+          <a:p>
+            <a:pPr algn="ctr"/>
+          </a:p>
+        </p:txBody>
+      </p:sp>
+      <p:sp>
+        <p:nvSpPr>
+          <p:cNvPr id="21" name="TextBox 20"/>
+          <p:cNvSpPr txBox="1"/>
+          <p:nvPr/>
+        </p:nvSpPr>
+        <p:spPr>
+          <a:xfrm>
+            <a:off x="9272016" y="2944368"/>
+            <a:ext cx="2423160" cy="320040"/>
+          </a:xfrm>
+          <a:prstGeom prst="rect">
+            <a:avLst/>
+          </a:prstGeom>
+          <a:noFill/>
+        </p:spPr>
+        <p:txBody>
+          <a:bodyPr wrap="none">
+            <a:spAutoFit/>
+          </a:bodyPr>
+          <a:lstStyle/>
+          <a:p>
+            <a:r>
+              <a:rPr sz="1100" b="1">
+                <a:solidFill>
+                  <a:srgbClr val="E86A1F"/>
+                </a:solidFill>
+                <a:latin typeface="Calibri"/>
+              </a:rPr>
+              <a:t>4. CV Scorer</a:t>
+            </a:r>
+          </a:p>
+        </p:txBody>
+      </p:sp>
+      <p:sp>
+        <p:nvSpPr>
+          <p:cNvPr id="22" name="TextBox 21"/>
+          <p:cNvSpPr txBox="1"/>
+          <p:nvPr/>
+        </p:nvSpPr>
+        <p:spPr>
+          <a:xfrm>
+            <a:off x="9272016" y="3246120"/>
+            <a:ext cx="2423160" cy="320040"/>
+          </a:xfrm>
+          <a:prstGeom prst="rect">
+            <a:avLst/>
+          </a:prstGeom>
+          <a:noFill/>
+        </p:spPr>
+        <p:txBody>
+          <a:bodyPr wrap="none">
+            <a:spAutoFit/>
+          </a:bodyPr>
+          <a:lstStyle/>
+          <a:p>
+            <a:r>
+              <a:rPr sz="1400" b="1">
+                <a:solidFill>
+                  <a:srgbClr val="142A55"/>
+                </a:solidFill>
+                <a:latin typeface="Calibri"/>
+              </a:rPr>
+              <a:t>OpenCV (Template / SSIM / ORB)</a:t>
+            </a:r>
+          </a:p>
+        </p:txBody>
+      </p:sp>
+      <p:sp>
+        <p:nvSpPr>
+          <p:cNvPr id="23" name="TextBox 22"/>
+          <p:cNvSpPr txBox="1"/>
+          <p:nvPr/>
+        </p:nvSpPr>
+        <p:spPr>
+          <a:xfrm>
+            <a:off x="9272016" y="3611880"/>
+            <a:ext cx="2423160" cy="1417320"/>
+          </a:xfrm>
+          <a:prstGeom prst="rect">
+            <a:avLst/>
+          </a:prstGeom>
+          <a:noFill/>
+        </p:spPr>
+        <p:txBody>
+          <a:bodyPr wrap="square">
+            <a:spAutoFit/>
+          </a:bodyPr>
+          <a:lstStyle/>
+          <a:p>
+            <a:pPr>
+              <a:spcAft>
+                <a:spcPts val="300"/>
+              </a:spcAft>
+            </a:pPr>
+            <a:r>
+              <a:rPr sz="1050" b="0">
+                <a:solidFill>
+                  <a:srgbClr val="222933"/>
+                </a:solidFill>
+                <a:latin typeface="Calibri"/>
+              </a:rPr>
+              <a:t>역할: 프레임-템플릿 유사도를 정량 점수화하여 stateless VLM 의 기억을 대신한다</a:t>
+            </a:r>
+          </a:p>
+          <a:p>
+            <a:pPr>
+              <a:spcAft>
+                <a:spcPts val="300"/>
+              </a:spcAft>
+            </a:pPr>
+            <a:r>
+              <a:rPr sz="1050" b="0">
+                <a:solidFill>
+                  <a:srgbClr val="556070"/>
+                </a:solidFill>
+                <a:latin typeface="Calibri"/>
+              </a:rPr>
+              <a:t>산출: 수치 매칭 점수 + best-frame 좌표</a:t>
+            </a:r>
+          </a:p>
+        </p:txBody>
+      </p:sp>
+      <p:sp>
+        <p:nvSpPr>
+          <p:cNvPr id="24" name="Rounded Rectangle 23"/>
+          <p:cNvSpPr/>
+          <p:nvPr/>
+        </p:nvSpPr>
+        <p:spPr>
+          <a:xfrm>
+            <a:off x="365760" y="5349240"/>
+            <a:ext cx="11475720" cy="1005840"/>
+          </a:xfrm>
+          <a:prstGeom prst="roundRect">
+            <a:avLst/>
+          </a:prstGeom>
+          <a:solidFill>
+            <a:srgbClr val="F4F6FA"/>
+          </a:solidFill>
+          <a:ln w="9525">
+            <a:solidFill>
+              <a:srgbClr val="142A55"/>
+            </a:solidFill>
+          </a:ln>
+          <a:effectLst/>
+        </p:spPr>
+        <p:style>
+          <a:lnRef idx="1">
+            <a:schemeClr val="accent1"/>
+          </a:lnRef>
+          <a:fillRef idx="3">
+            <a:schemeClr val="accent1"/>
+          </a:fillRef>
+          <a:effectRef idx="2">
+            <a:schemeClr val="accent1"/>
+          </a:effectRef>
+          <a:fontRef idx="minor">
+            <a:schemeClr val="lt1"/>
+          </a:fontRef>
+        </p:style>
+        <p:txBody>
+          <a:bodyPr rtlCol="0" anchor="ctr"/>
+          <a:lstStyle/>
+          <a:p>
+            <a:pPr algn="ctr"/>
+          </a:p>
+        </p:txBody>
+      </p:sp>
+      <p:sp>
+        <p:nvSpPr>
+          <p:cNvPr id="25" name="TextBox 24"/>
+          <p:cNvSpPr txBox="1"/>
+          <p:nvPr/>
+        </p:nvSpPr>
+        <p:spPr>
+          <a:xfrm>
+            <a:off x="594360" y="5486400"/>
+            <a:ext cx="11018520" cy="411480"/>
+          </a:xfrm>
+          <a:prstGeom prst="rect">
+            <a:avLst/>
+          </a:prstGeom>
+          <a:noFill/>
+        </p:spPr>
+        <p:txBody>
+          <a:bodyPr wrap="none">
+            <a:spAutoFit/>
+          </a:bodyPr>
+          <a:lstStyle/>
+          <a:p>
+            <a:r>
+              <a:rPr sz="1600" b="1">
+                <a:solidFill>
+                  <a:srgbClr val="142A55"/>
+                </a:solidFill>
+                <a:latin typeface="Calibri"/>
+              </a:rPr>
+              <a:t>협력으로 얻는 것</a:t>
+            </a:r>
+          </a:p>
+        </p:txBody>
+      </p:sp>
+      <p:sp>
+        <p:nvSpPr>
+          <p:cNvPr id="26" name="TextBox 25"/>
+          <p:cNvSpPr txBox="1"/>
+          <p:nvPr/>
+        </p:nvSpPr>
+        <p:spPr>
+          <a:xfrm>
+            <a:off x="594360" y="5943600"/>
+            <a:ext cx="11018520" cy="274320"/>
+          </a:xfrm>
+          <a:prstGeom prst="rect">
+            <a:avLst/>
+          </a:prstGeom>
+          <a:noFill/>
+        </p:spPr>
+        <p:txBody>
+          <a:bodyPr wrap="square">
+            <a:spAutoFit/>
+          </a:bodyPr>
+          <a:lstStyle/>
+          <a:p>
+            <a:pPr>
+              <a:spcAft>
+                <a:spcPts val="400"/>
+              </a:spcAft>
+            </a:pPr>
+            <a:r>
+              <a:rPr sz="1200" b="0">
+                <a:solidFill>
+                  <a:srgbClr val="222933"/>
+                </a:solidFill>
+                <a:latin typeface="Calibri"/>
+              </a:rPr>
+              <a:t>• 정확도: Coarse → Fine 분리로 클릭 좌표 오차를 ‘대략 영역’ 수준에서 ‘픽셀’ 수준으로 축소</a:t>
+            </a:r>
+          </a:p>
+          <a:p>
+            <a:pPr>
+              <a:spcAft>
+                <a:spcPts val="400"/>
+              </a:spcAft>
+            </a:pPr>
+            <a:r>
+              <a:rPr sz="1200" b="0">
+                <a:solidFill>
+                  <a:srgbClr val="222933"/>
+                </a:solidFill>
+                <a:latin typeface="Calibri"/>
+              </a:rPr>
+              <a:t>• 검증성: 액션 → OCR 검증 → 다음 액션 의 폐루프(closed-loop) 자동화로 무인 신뢰도 확보</a:t>
+            </a:r>
+          </a:p>
+        </p:txBody>
+      </p:sp>
+      <p:sp>
+        <p:nvSpPr>
+          <p:cNvPr id="27" name="TextBox 26"/>
+          <p:cNvSpPr txBox="1"/>
+          <p:nvPr/>
+        </p:nvSpPr>
+        <p:spPr>
+          <a:xfrm>
+            <a:off x="365760" y="6446520"/>
+            <a:ext cx="11430000" cy="274320"/>
+          </a:xfrm>
+          <a:prstGeom prst="rect">
+            <a:avLst/>
+          </a:prstGeom>
+          <a:noFill/>
+        </p:spPr>
+        <p:txBody>
+          <a:bodyPr wrap="none">
+            <a:spAutoFit/>
+          </a:bodyPr>
+          <a:lstStyle/>
+          <a:p>
+            <a:r>
+              <a:rPr sz="1000" b="0">
+                <a:solidFill>
+                  <a:srgbClr val="556070"/>
+                </a:solidFill>
+                <a:latin typeface="Calibri"/>
+              </a:rPr>
+              <a:t>UI-Venus + MAI-UI + PaddleOCR-VL + OpenCV  =  GUI 자동화에 필요한 능력의 모듈식 조합</a:t>
+            </a:r>
+          </a:p>
+        </p:txBody>
+      </p:sp>
+    </p:spTree>
+  </p:cSld>
+  <p:clrMapOvr>
+    <a:masterClrMapping/>
+  </p:clrMapOvr>
+</p:sld>
+</file>
+
+<file path=ppt/slides/slide4.xml><?xml version="1.0" encoding="utf-8"?>
+<p:sld xmlns:a="http://schemas.openxmlformats.org/drawingml/2006/main" xmlns:p="http://schemas.openxmlformats.org/presentationml/2006/main" xmlns:r="http://schemas.openxmlformats.org/officeDocument/2006/relationships">
+  <p:cSld>
+    <p:spTree>
+      <p:nvGrpSpPr>
+        <p:cNvPr id="1" name=""/>
+        <p:cNvGrpSpPr/>
+        <p:nvPr/>
+      </p:nvGrpSpPr>
+      <p:grpSpPr/>
+      <p:sp>
+        <p:nvSpPr>
+          <p:cNvPr id="2" name="Rectangle 1"/>
+          <p:cNvSpPr/>
+          <p:nvPr/>
+        </p:nvSpPr>
+        <p:spPr>
+          <a:xfrm>
+            <a:off x="0" y="0"/>
+            <a:ext cx="12191695" cy="1005840"/>
+          </a:xfrm>
+          <a:prstGeom prst="rect">
+            <a:avLst/>
+          </a:prstGeom>
+          <a:solidFill>
+            <a:srgbClr val="142A55"/>
+          </a:solidFill>
+          <a:ln>
+            <a:noFill/>
+          </a:ln>
+        </p:spPr>
+        <p:style>
+          <a:lnRef idx="1">
+            <a:schemeClr val="accent1"/>
+          </a:lnRef>
+          <a:fillRef idx="3">
+            <a:schemeClr val="accent1"/>
+          </a:fillRef>
+          <a:effectRef idx="2">
+            <a:schemeClr val="accent1"/>
+          </a:effectRef>
+          <a:fontRef idx="minor">
+            <a:schemeClr val="lt1"/>
+          </a:fontRef>
+        </p:style>
+        <p:txBody>
+          <a:bodyPr rtlCol="0" anchor="ctr"/>
+          <a:lstStyle/>
+          <a:p>
+            <a:pPr algn="ctr"/>
+          </a:p>
+        </p:txBody>
+      </p:sp>
+      <p:sp>
+        <p:nvSpPr>
+          <p:cNvPr id="3" name="TextBox 2"/>
+          <p:cNvSpPr txBox="1"/>
+          <p:nvPr/>
+        </p:nvSpPr>
+        <p:spPr>
+          <a:xfrm>
+            <a:off x="365760" y="137160"/>
+            <a:ext cx="11430000" cy="502920"/>
+          </a:xfrm>
+          <a:prstGeom prst="rect">
+            <a:avLst/>
+          </a:prstGeom>
+          <a:noFill/>
+        </p:spPr>
+        <p:txBody>
+          <a:bodyPr wrap="none" lIns="0" rIns="0">
+            <a:spAutoFit/>
+          </a:bodyPr>
+          <a:lstStyle/>
+          <a:p>
+            <a:r>
+              <a:rPr sz="2600" b="1">
+                <a:solidFill>
+                  <a:srgbClr val="FFFFFF"/>
+                </a:solidFill>
+                <a:latin typeface="Calibri"/>
+              </a:rPr>
+              <a:t>협력 파이프라인: Coarse → Zoom → Fine → Verify</a:t>
+            </a:r>
+          </a:p>
+        </p:txBody>
+      </p:sp>
+      <p:sp>
+        <p:nvSpPr>
+          <p:cNvPr id="4" name="TextBox 3"/>
+          <p:cNvSpPr txBox="1"/>
+          <p:nvPr/>
+        </p:nvSpPr>
+        <p:spPr>
+          <a:xfrm>
+            <a:off x="365760" y="640080"/>
+            <a:ext cx="11430000" cy="320040"/>
+          </a:xfrm>
+          <a:prstGeom prst="rect">
+            <a:avLst/>
+          </a:prstGeom>
+          <a:noFill/>
+        </p:spPr>
+        <p:txBody>
+          <a:bodyPr wrap="none">
+            <a:spAutoFit/>
+          </a:bodyPr>
+          <a:lstStyle/>
+          <a:p>
+            <a:r>
+              <a:rPr sz="1300" b="0">
+                <a:solidFill>
+                  <a:srgbClr val="CDD7E6"/>
+                </a:solidFill>
+                <a:latin typeface="Calibri"/>
+              </a:rPr>
+              <a:t>RCS 로그인 자동화에서 실제 동작하는 다중 모델 협업 흐름</a:t>
+            </a:r>
+          </a:p>
+        </p:txBody>
+      </p:sp>
+      <p:sp>
+        <p:nvSpPr>
+          <p:cNvPr id="5" name="Rounded Rectangle 4"/>
+          <p:cNvSpPr/>
+          <p:nvPr/>
+        </p:nvSpPr>
+        <p:spPr>
+          <a:xfrm>
+            <a:off x="365760" y="1371600"/>
+            <a:ext cx="2240280" cy="1417320"/>
+          </a:xfrm>
+          <a:prstGeom prst="roundRect">
+            <a:avLst/>
+          </a:prstGeom>
+          <a:solidFill>
+            <a:srgbClr val="FFFFFF"/>
+          </a:solidFill>
+          <a:ln w="15875">
+            <a:solidFill>
+              <a:srgbClr val="E86A1F"/>
+            </a:solidFill>
+          </a:ln>
+          <a:effectLst/>
+        </p:spPr>
+        <p:style>
+          <a:lnRef idx="1">
+            <a:schemeClr val="accent1"/>
+          </a:lnRef>
+          <a:fillRef idx="3">
+            <a:schemeClr val="accent1"/>
+          </a:fillRef>
+          <a:effectRef idx="2">
+            <a:schemeClr val="accent1"/>
+          </a:effectRef>
+          <a:fontRef idx="minor">
+            <a:schemeClr val="lt1"/>
+          </a:fontRef>
+        </p:style>
+        <p:txBody>
+          <a:bodyPr rtlCol="0" anchor="ctr"/>
+          <a:lstStyle/>
+          <a:p>
+            <a:pPr algn="ctr"/>
+          </a:p>
+        </p:txBody>
+      </p:sp>
+      <p:sp>
+        <p:nvSpPr>
+          <p:cNvPr id="6" name="Oval 5"/>
+          <p:cNvSpPr/>
+          <p:nvPr/>
+        </p:nvSpPr>
+        <p:spPr>
+          <a:xfrm>
+            <a:off x="502920" y="1508760"/>
+            <a:ext cx="365760" cy="365760"/>
+          </a:xfrm>
+          <a:prstGeom prst="ellipse">
+            <a:avLst/>
+          </a:prstGeom>
+          <a:solidFill>
+            <a:srgbClr val="E86A1F"/>
+          </a:solidFill>
+          <a:ln>
+            <a:noFill/>
+          </a:ln>
+        </p:spPr>
+        <p:style>
+          <a:lnRef idx="1">
+            <a:schemeClr val="accent1"/>
+          </a:lnRef>
+          <a:fillRef idx="3">
+            <a:schemeClr val="accent1"/>
+          </a:fillRef>
+          <a:effectRef idx="2">
+            <a:schemeClr val="accent1"/>
+          </a:effectRef>
+          <a:fontRef idx="minor">
+            <a:schemeClr val="lt1"/>
+          </a:fontRef>
+        </p:style>
+        <p:txBody>
+          <a:bodyPr rtlCol="0" anchor="ctr" lIns="0" rIns="0" tIns="0" bIns="0"/>
+          <a:lstStyle/>
+          <a:p>
+            <a:pPr algn="ctr"/>
+            <a:r>
+              <a:rPr sz="1200" b="1">
+                <a:solidFill>
+                  <a:srgbClr val="FFFFFF"/>
+                </a:solidFill>
+                <a:latin typeface="Calibri"/>
+              </a:rPr>
+              <a:t>1</a:t>
+            </a:r>
+          </a:p>
+        </p:txBody>
+      </p:sp>
+      <p:sp>
+        <p:nvSpPr>
+          <p:cNvPr id="7" name="TextBox 6"/>
+          <p:cNvSpPr txBox="1"/>
+          <p:nvPr/>
+        </p:nvSpPr>
+        <p:spPr>
+          <a:xfrm>
+            <a:off x="960120" y="1481328"/>
+            <a:ext cx="1508760" cy="365760"/>
+          </a:xfrm>
+          <a:prstGeom prst="rect">
+            <a:avLst/>
+          </a:prstGeom>
+          <a:noFill/>
+        </p:spPr>
+        <p:txBody>
+          <a:bodyPr wrap="none">
+            <a:spAutoFit/>
+          </a:bodyPr>
+          <a:lstStyle/>
+          <a:p>
+            <a:r>
+              <a:rPr sz="1300" b="1">
+                <a:solidFill>
+                  <a:srgbClr val="142A55"/>
+                </a:solidFill>
+                <a:latin typeface="Calibri"/>
+              </a:rPr>
+              <a:t>Capture</a:t>
+            </a:r>
+          </a:p>
+        </p:txBody>
+      </p:sp>
+      <p:sp>
+        <p:nvSpPr>
+          <p:cNvPr id="8" name="TextBox 7"/>
+          <p:cNvSpPr txBox="1"/>
+          <p:nvPr/>
+        </p:nvSpPr>
+        <p:spPr>
+          <a:xfrm>
+            <a:off x="548640" y="1920240"/>
+            <a:ext cx="1874520" cy="777240"/>
+          </a:xfrm>
+          <a:prstGeom prst="rect">
+            <a:avLst/>
+          </a:prstGeom>
+          <a:noFill/>
+        </p:spPr>
+        <p:txBody>
+          <a:bodyPr wrap="square">
+            <a:spAutoFit/>
+          </a:bodyPr>
+          <a:lstStyle/>
+          <a:p>
+            <a:r>
+              <a:rPr sz="1050" b="0">
+                <a:solidFill>
+                  <a:srgbClr val="556070"/>
+                </a:solidFill>
+                <a:latin typeface="Calibri"/>
+              </a:rPr>
+              <a:t>RCS 로그인 창을 캡처하여 WebP 로 인코딩 후 Flask 프록시로 전달</a:t>
+            </a:r>
+          </a:p>
+        </p:txBody>
+      </p:sp>
+      <p:sp>
+        <p:nvSpPr>
+          <p:cNvPr id="9" name="Rounded Rectangle 8"/>
+          <p:cNvSpPr/>
+          <p:nvPr/>
+        </p:nvSpPr>
+        <p:spPr>
+          <a:xfrm>
+            <a:off x="2670048" y="1371600"/>
+            <a:ext cx="2240280" cy="1417320"/>
+          </a:xfrm>
+          <a:prstGeom prst="roundRect">
+            <a:avLst/>
+          </a:prstGeom>
+          <a:solidFill>
+            <a:srgbClr val="FFFFFF"/>
+          </a:solidFill>
+          <a:ln w="15875">
+            <a:solidFill>
+              <a:srgbClr val="E86A1F"/>
+            </a:solidFill>
+          </a:ln>
+          <a:effectLst/>
+        </p:spPr>
+        <p:style>
+          <a:lnRef idx="1">
+            <a:schemeClr val="accent1"/>
+          </a:lnRef>
+          <a:fillRef idx="3">
+            <a:schemeClr val="accent1"/>
+          </a:fillRef>
+          <a:effectRef idx="2">
+            <a:schemeClr val="accent1"/>
+          </a:effectRef>
+          <a:fontRef idx="minor">
+            <a:schemeClr val="lt1"/>
+          </a:fontRef>
+        </p:style>
+        <p:txBody>
+          <a:bodyPr rtlCol="0" anchor="ctr"/>
+          <a:lstStyle/>
+          <a:p>
+            <a:pPr algn="ctr"/>
+          </a:p>
+        </p:txBody>
+      </p:sp>
+      <p:sp>
+        <p:nvSpPr>
+          <p:cNvPr id="10" name="Oval 9"/>
+          <p:cNvSpPr/>
+          <p:nvPr/>
+        </p:nvSpPr>
+        <p:spPr>
+          <a:xfrm>
+            <a:off x="2807208" y="1508760"/>
+            <a:ext cx="365760" cy="365760"/>
+          </a:xfrm>
+          <a:prstGeom prst="ellipse">
+            <a:avLst/>
+          </a:prstGeom>
+          <a:solidFill>
+            <a:srgbClr val="E86A1F"/>
+          </a:solidFill>
+          <a:ln>
+            <a:noFill/>
+          </a:ln>
+        </p:spPr>
+        <p:style>
+          <a:lnRef idx="1">
+            <a:schemeClr val="accent1"/>
+          </a:lnRef>
+          <a:fillRef idx="3">
+            <a:schemeClr val="accent1"/>
+          </a:fillRef>
+          <a:effectRef idx="2">
+            <a:schemeClr val="accent1"/>
+          </a:effectRef>
+          <a:fontRef idx="minor">
+            <a:schemeClr val="lt1"/>
+          </a:fontRef>
+        </p:style>
+        <p:txBody>
+          <a:bodyPr rtlCol="0" anchor="ctr" lIns="0" rIns="0" tIns="0" bIns="0"/>
+          <a:lstStyle/>
+          <a:p>
+            <a:pPr algn="ctr"/>
+            <a:r>
+              <a:rPr sz="1200" b="1">
+                <a:solidFill>
+                  <a:srgbClr val="FFFFFF"/>
+                </a:solidFill>
+                <a:latin typeface="Calibri"/>
+              </a:rPr>
+              <a:t>2</a:t>
+            </a:r>
+          </a:p>
+        </p:txBody>
+      </p:sp>
+      <p:sp>
+        <p:nvSpPr>
+          <p:cNvPr id="11" name="TextBox 10"/>
+          <p:cNvSpPr txBox="1"/>
+          <p:nvPr/>
+        </p:nvSpPr>
+        <p:spPr>
+          <a:xfrm>
+            <a:off x="3264408" y="1481328"/>
+            <a:ext cx="1508760" cy="365760"/>
+          </a:xfrm>
+          <a:prstGeom prst="rect">
+            <a:avLst/>
+          </a:prstGeom>
+          <a:noFill/>
+        </p:spPr>
+        <p:txBody>
+          <a:bodyPr wrap="none">
+            <a:spAutoFit/>
+          </a:bodyPr>
+          <a:lstStyle/>
+          <a:p>
+            <a:r>
+              <a:rPr sz="1300" b="1">
+                <a:solidFill>
+                  <a:srgbClr val="142A55"/>
+                </a:solidFill>
+                <a:latin typeface="Calibri"/>
+              </a:rPr>
+              <a:t>UI-Venus</a:t>
+            </a:r>
+          </a:p>
+        </p:txBody>
+      </p:sp>
+      <p:sp>
+        <p:nvSpPr>
+          <p:cNvPr id="12" name="TextBox 11"/>
+          <p:cNvSpPr txBox="1"/>
+          <p:nvPr/>
+        </p:nvSpPr>
+        <p:spPr>
+          <a:xfrm>
+            <a:off x="2852928" y="1920240"/>
+            <a:ext cx="1874520" cy="777240"/>
+          </a:xfrm>
+          <a:prstGeom prst="rect">
+            <a:avLst/>
+          </a:prstGeom>
+          <a:noFill/>
+        </p:spPr>
+        <p:txBody>
+          <a:bodyPr wrap="square">
+            <a:spAutoFit/>
+          </a:bodyPr>
+          <a:lstStyle/>
+          <a:p>
+            <a:r>
+              <a:rPr sz="1050" b="0">
+                <a:solidFill>
+                  <a:srgbClr val="556070"/>
+                </a:solidFill>
+                <a:latin typeface="Calibri"/>
+              </a:rPr>
+              <a:t>전체 이미지에서 'User ID 입력 필드' 의 coarse bbox(gold) 를 추출</a:t>
+            </a:r>
+          </a:p>
+        </p:txBody>
+      </p:sp>
+      <p:sp>
+        <p:nvSpPr>
+          <p:cNvPr id="13" name="Rounded Rectangle 12"/>
+          <p:cNvSpPr/>
+          <p:nvPr/>
+        </p:nvSpPr>
+        <p:spPr>
+          <a:xfrm>
+            <a:off x="4974336" y="1371600"/>
+            <a:ext cx="2240280" cy="1417320"/>
+          </a:xfrm>
+          <a:prstGeom prst="roundRect">
+            <a:avLst/>
+          </a:prstGeom>
+          <a:solidFill>
+            <a:srgbClr val="FFFFFF"/>
+          </a:solidFill>
+          <a:ln w="15875">
+            <a:solidFill>
+              <a:srgbClr val="E86A1F"/>
+            </a:solidFill>
+          </a:ln>
+          <a:effectLst/>
+        </p:spPr>
+        <p:style>
+          <a:lnRef idx="1">
+            <a:schemeClr val="accent1"/>
+          </a:lnRef>
+          <a:fillRef idx="3">
+            <a:schemeClr val="accent1"/>
+          </a:fillRef>
+          <a:effectRef idx="2">
+            <a:schemeClr val="accent1"/>
+          </a:effectRef>
+          <a:fontRef idx="minor">
+            <a:schemeClr val="lt1"/>
+          </a:fontRef>
+        </p:style>
+        <p:txBody>
+          <a:bodyPr rtlCol="0" anchor="ctr"/>
+          <a:lstStyle/>
+          <a:p>
+            <a:pPr algn="ctr"/>
+          </a:p>
+        </p:txBody>
+      </p:sp>
+      <p:sp>
+        <p:nvSpPr>
+          <p:cNvPr id="14" name="Oval 13"/>
+          <p:cNvSpPr/>
+          <p:nvPr/>
+        </p:nvSpPr>
+        <p:spPr>
+          <a:xfrm>
+            <a:off x="5111496" y="1508760"/>
+            <a:ext cx="365760" cy="365760"/>
+          </a:xfrm>
+          <a:prstGeom prst="ellipse">
+            <a:avLst/>
+          </a:prstGeom>
+          <a:solidFill>
+            <a:srgbClr val="E86A1F"/>
+          </a:solidFill>
+          <a:ln>
+            <a:noFill/>
+          </a:ln>
+        </p:spPr>
+        <p:style>
+          <a:lnRef idx="1">
+            <a:schemeClr val="accent1"/>
+          </a:lnRef>
+          <a:fillRef idx="3">
+            <a:schemeClr val="accent1"/>
+          </a:fillRef>
+          <a:effectRef idx="2">
+            <a:schemeClr val="accent1"/>
+          </a:effectRef>
+          <a:fontRef idx="minor">
+            <a:schemeClr val="lt1"/>
+          </a:fontRef>
+        </p:style>
+        <p:txBody>
+          <a:bodyPr rtlCol="0" anchor="ctr" lIns="0" rIns="0" tIns="0" bIns="0"/>
+          <a:lstStyle/>
+          <a:p>
+            <a:pPr algn="ctr"/>
+            <a:r>
+              <a:rPr sz="1200" b="1">
+                <a:solidFill>
+                  <a:srgbClr val="FFFFFF"/>
+                </a:solidFill>
+                <a:latin typeface="Calibri"/>
+              </a:rPr>
+              <a:t>3</a:t>
+            </a:r>
+          </a:p>
+        </p:txBody>
+      </p:sp>
+      <p:sp>
+        <p:nvSpPr>
+          <p:cNvPr id="15" name="TextBox 14"/>
+          <p:cNvSpPr txBox="1"/>
+          <p:nvPr/>
+        </p:nvSpPr>
+        <p:spPr>
+          <a:xfrm>
+            <a:off x="5568696" y="1481328"/>
+            <a:ext cx="1508760" cy="365760"/>
+          </a:xfrm>
+          <a:prstGeom prst="rect">
+            <a:avLst/>
+          </a:prstGeom>
+          <a:noFill/>
+        </p:spPr>
+        <p:txBody>
+          <a:bodyPr wrap="none">
+            <a:spAutoFit/>
+          </a:bodyPr>
+          <a:lstStyle/>
+          <a:p>
+            <a:r>
+              <a:rPr sz="1300" b="1">
+                <a:solidFill>
+                  <a:srgbClr val="142A55"/>
+                </a:solidFill>
+                <a:latin typeface="Calibri"/>
+              </a:rPr>
+              <a:t>Crop &amp; Zoom</a:t>
+            </a:r>
+          </a:p>
+        </p:txBody>
+      </p:sp>
+      <p:sp>
+        <p:nvSpPr>
+          <p:cNvPr id="16" name="TextBox 15"/>
+          <p:cNvSpPr txBox="1"/>
+          <p:nvPr/>
+        </p:nvSpPr>
+        <p:spPr>
+          <a:xfrm>
+            <a:off x="5157216" y="1920240"/>
+            <a:ext cx="1874520" cy="777240"/>
+          </a:xfrm>
+          <a:prstGeom prst="rect">
+            <a:avLst/>
+          </a:prstGeom>
+          <a:noFill/>
+        </p:spPr>
+        <p:txBody>
+          <a:bodyPr wrap="square">
+            <a:spAutoFit/>
+          </a:bodyPr>
+          <a:lstStyle/>
+          <a:p>
+            <a:r>
+              <a:rPr sz="1050" b="0">
+                <a:solidFill>
+                  <a:srgbClr val="556070"/>
+                </a:solidFill>
+                <a:latin typeface="Calibri"/>
+              </a:rPr>
+              <a:t>Coarse bbox 주변에 padding 을 더해 잘라내고 확대하여 디테일 보존</a:t>
+            </a:r>
+          </a:p>
+        </p:txBody>
+      </p:sp>
+      <p:sp>
+        <p:nvSpPr>
+          <p:cNvPr id="17" name="Rounded Rectangle 16"/>
+          <p:cNvSpPr/>
+          <p:nvPr/>
+        </p:nvSpPr>
+        <p:spPr>
+          <a:xfrm>
+            <a:off x="7278624" y="1371600"/>
+            <a:ext cx="2240280" cy="1417320"/>
+          </a:xfrm>
+          <a:prstGeom prst="roundRect">
+            <a:avLst/>
+          </a:prstGeom>
+          <a:solidFill>
+            <a:srgbClr val="FFFFFF"/>
+          </a:solidFill>
+          <a:ln w="15875">
+            <a:solidFill>
+              <a:srgbClr val="E86A1F"/>
+            </a:solidFill>
+          </a:ln>
+          <a:effectLst/>
+        </p:spPr>
+        <p:style>
+          <a:lnRef idx="1">
+            <a:schemeClr val="accent1"/>
+          </a:lnRef>
+          <a:fillRef idx="3">
+            <a:schemeClr val="accent1"/>
+          </a:fillRef>
+          <a:effectRef idx="2">
+            <a:schemeClr val="accent1"/>
+          </a:effectRef>
+          <a:fontRef idx="minor">
+            <a:schemeClr val="lt1"/>
+          </a:fontRef>
+        </p:style>
+        <p:txBody>
+          <a:bodyPr rtlCol="0" anchor="ctr"/>
+          <a:lstStyle/>
+          <a:p>
+            <a:pPr algn="ctr"/>
+          </a:p>
+        </p:txBody>
+      </p:sp>
+      <p:sp>
+        <p:nvSpPr>
+          <p:cNvPr id="18" name="Oval 17"/>
+          <p:cNvSpPr/>
+          <p:nvPr/>
+        </p:nvSpPr>
+        <p:spPr>
+          <a:xfrm>
+            <a:off x="7415784" y="1508760"/>
+            <a:ext cx="365760" cy="365760"/>
+          </a:xfrm>
+          <a:prstGeom prst="ellipse">
+            <a:avLst/>
+          </a:prstGeom>
+          <a:solidFill>
+            <a:srgbClr val="E86A1F"/>
+          </a:solidFill>
+          <a:ln>
+            <a:noFill/>
+          </a:ln>
+        </p:spPr>
+        <p:style>
+          <a:lnRef idx="1">
+            <a:schemeClr val="accent1"/>
+          </a:lnRef>
+          <a:fillRef idx="3">
+            <a:schemeClr val="accent1"/>
+          </a:fillRef>
+          <a:effectRef idx="2">
+            <a:schemeClr val="accent1"/>
+          </a:effectRef>
+          <a:fontRef idx="minor">
+            <a:schemeClr val="lt1"/>
+          </a:fontRef>
+        </p:style>
+        <p:txBody>
+          <a:bodyPr rtlCol="0" anchor="ctr" lIns="0" rIns="0" tIns="0" bIns="0"/>
+          <a:lstStyle/>
+          <a:p>
+            <a:pPr algn="ctr"/>
+            <a:r>
+              <a:rPr sz="1200" b="1">
+                <a:solidFill>
+                  <a:srgbClr val="FFFFFF"/>
+                </a:solidFill>
+                <a:latin typeface="Calibri"/>
+              </a:rPr>
+              <a:t>4</a:t>
+            </a:r>
+          </a:p>
+        </p:txBody>
+      </p:sp>
+      <p:sp>
+        <p:nvSpPr>
+          <p:cNvPr id="19" name="TextBox 18"/>
+          <p:cNvSpPr txBox="1"/>
+          <p:nvPr/>
+        </p:nvSpPr>
+        <p:spPr>
+          <a:xfrm>
+            <a:off x="7872984" y="1481328"/>
+            <a:ext cx="1508760" cy="365760"/>
+          </a:xfrm>
+          <a:prstGeom prst="rect">
+            <a:avLst/>
+          </a:prstGeom>
+          <a:noFill/>
+        </p:spPr>
+        <p:txBody>
+          <a:bodyPr wrap="none">
+            <a:spAutoFit/>
+          </a:bodyPr>
+          <a:lstStyle/>
+          <a:p>
+            <a:r>
+              <a:rPr sz="1300" b="1">
+                <a:solidFill>
+                  <a:srgbClr val="142A55"/>
+                </a:solidFill>
+                <a:latin typeface="Calibri"/>
+              </a:rPr>
+              <a:t>MAI-UI</a:t>
+            </a:r>
+          </a:p>
+        </p:txBody>
+      </p:sp>
+      <p:sp>
+        <p:nvSpPr>
+          <p:cNvPr id="20" name="TextBox 19"/>
+          <p:cNvSpPr txBox="1"/>
+          <p:nvPr/>
+        </p:nvSpPr>
+        <p:spPr>
+          <a:xfrm>
+            <a:off x="7461504" y="1920240"/>
+            <a:ext cx="1874520" cy="777240"/>
+          </a:xfrm>
+          <a:prstGeom prst="rect">
+            <a:avLst/>
+          </a:prstGeom>
+          <a:noFill/>
+        </p:spPr>
+        <p:txBody>
+          <a:bodyPr wrap="square">
+            <a:spAutoFit/>
+          </a:bodyPr>
+          <a:lstStyle/>
+          <a:p>
+            <a:r>
+              <a:rPr sz="1050" b="0">
+                <a:solidFill>
+                  <a:srgbClr val="556070"/>
+                </a:solidFill>
+                <a:latin typeface="Calibri"/>
+              </a:rPr>
+              <a:t>Zoom crop 에서 refined 클릭 포인트(deepskyblue) 를 픽셀 단위로 결정</a:t>
+            </a:r>
+          </a:p>
+        </p:txBody>
+      </p:sp>
+      <p:sp>
+        <p:nvSpPr>
+          <p:cNvPr id="21" name="Rounded Rectangle 20"/>
+          <p:cNvSpPr/>
+          <p:nvPr/>
+        </p:nvSpPr>
+        <p:spPr>
+          <a:xfrm>
+            <a:off x="9582912" y="1371600"/>
+            <a:ext cx="2240280" cy="1417320"/>
+          </a:xfrm>
+          <a:prstGeom prst="roundRect">
+            <a:avLst/>
+          </a:prstGeom>
+          <a:solidFill>
+            <a:srgbClr val="FFFFFF"/>
+          </a:solidFill>
+          <a:ln w="15875">
+            <a:solidFill>
+              <a:srgbClr val="E86A1F"/>
+            </a:solidFill>
+          </a:ln>
+          <a:effectLst/>
+        </p:spPr>
+        <p:style>
+          <a:lnRef idx="1">
+            <a:schemeClr val="accent1"/>
+          </a:lnRef>
+          <a:fillRef idx="3">
+            <a:schemeClr val="accent1"/>
+          </a:fillRef>
+          <a:effectRef idx="2">
+            <a:schemeClr val="accent1"/>
+          </a:effectRef>
+          <a:fontRef idx="minor">
+            <a:schemeClr val="lt1"/>
+          </a:fontRef>
+        </p:style>
+        <p:txBody>
+          <a:bodyPr rtlCol="0" anchor="ctr"/>
+          <a:lstStyle/>
+          <a:p>
+            <a:pPr algn="ctr"/>
+          </a:p>
+        </p:txBody>
+      </p:sp>
+      <p:sp>
+        <p:nvSpPr>
+          <p:cNvPr id="22" name="Oval 21"/>
+          <p:cNvSpPr/>
+          <p:nvPr/>
+        </p:nvSpPr>
+        <p:spPr>
+          <a:xfrm>
+            <a:off x="9720072" y="1508760"/>
+            <a:ext cx="365760" cy="365760"/>
+          </a:xfrm>
+          <a:prstGeom prst="ellipse">
+            <a:avLst/>
+          </a:prstGeom>
+          <a:solidFill>
+            <a:srgbClr val="E86A1F"/>
+          </a:solidFill>
+          <a:ln>
+            <a:noFill/>
+          </a:ln>
+        </p:spPr>
+        <p:style>
+          <a:lnRef idx="1">
+            <a:schemeClr val="accent1"/>
+          </a:lnRef>
+          <a:fillRef idx="3">
+            <a:schemeClr val="accent1"/>
+          </a:fillRef>
+          <a:effectRef idx="2">
+            <a:schemeClr val="accent1"/>
+          </a:effectRef>
+          <a:fontRef idx="minor">
+            <a:schemeClr val="lt1"/>
+          </a:fontRef>
+        </p:style>
+        <p:txBody>
+          <a:bodyPr rtlCol="0" anchor="ctr" lIns="0" rIns="0" tIns="0" bIns="0"/>
+          <a:lstStyle/>
+          <a:p>
+            <a:pPr algn="ctr"/>
+            <a:r>
+              <a:rPr sz="1200" b="1">
+                <a:solidFill>
+                  <a:srgbClr val="FFFFFF"/>
+                </a:solidFill>
+                <a:latin typeface="Calibri"/>
+              </a:rPr>
+              <a:t>5</a:t>
+            </a:r>
+          </a:p>
+        </p:txBody>
+      </p:sp>
+      <p:sp>
+        <p:nvSpPr>
+          <p:cNvPr id="23" name="TextBox 22"/>
+          <p:cNvSpPr txBox="1"/>
+          <p:nvPr/>
+        </p:nvSpPr>
+        <p:spPr>
+          <a:xfrm>
+            <a:off x="10177272" y="1481328"/>
+            <a:ext cx="1508760" cy="365760"/>
+          </a:xfrm>
+          <a:prstGeom prst="rect">
+            <a:avLst/>
+          </a:prstGeom>
+          <a:noFill/>
+        </p:spPr>
+        <p:txBody>
+          <a:bodyPr wrap="none">
+            <a:spAutoFit/>
+          </a:bodyPr>
+          <a:lstStyle/>
+          <a:p>
+            <a:r>
+              <a:rPr sz="1300" b="1">
+                <a:solidFill>
+                  <a:srgbClr val="142A55"/>
+                </a:solidFill>
+                <a:latin typeface="Calibri"/>
+              </a:rPr>
+              <a:t>PaddleOCR-VL</a:t>
+            </a:r>
+          </a:p>
+        </p:txBody>
+      </p:sp>
+      <p:sp>
+        <p:nvSpPr>
+          <p:cNvPr id="24" name="TextBox 23"/>
+          <p:cNvSpPr txBox="1"/>
+          <p:nvPr/>
+        </p:nvSpPr>
+        <p:spPr>
+          <a:xfrm>
+            <a:off x="9765792" y="1920240"/>
+            <a:ext cx="1874520" cy="777240"/>
+          </a:xfrm>
+          <a:prstGeom prst="rect">
+            <a:avLst/>
+          </a:prstGeom>
+          <a:noFill/>
+        </p:spPr>
+        <p:txBody>
+          <a:bodyPr wrap="square">
+            <a:spAutoFit/>
+          </a:bodyPr>
+          <a:lstStyle/>
+          <a:p>
+            <a:r>
+              <a:rPr sz="1050" b="0">
+                <a:solidFill>
+                  <a:srgbClr val="556070"/>
+                </a:solidFill>
+                <a:latin typeface="Calibri"/>
+              </a:rPr>
+              <a:t>클릭 → 키 입력 후 화면을 다시 OCR 하여 의도한 값이 입력됐는지 검증</a:t>
+            </a:r>
+          </a:p>
+        </p:txBody>
+      </p:sp>
+      <p:sp>
+        <p:nvSpPr>
+          <p:cNvPr id="25" name="Rounded Rectangle 24"/>
+          <p:cNvSpPr/>
+          <p:nvPr/>
+        </p:nvSpPr>
+        <p:spPr>
+          <a:xfrm>
+            <a:off x="365760" y="3017520"/>
+            <a:ext cx="5715000" cy="3246120"/>
+          </a:xfrm>
+          <a:prstGeom prst="roundRect">
+            <a:avLst/>
+          </a:prstGeom>
+          <a:solidFill>
+            <a:srgbClr val="F4F6FA"/>
+          </a:solidFill>
+          <a:ln w="9525">
+            <a:solidFill>
+              <a:srgbClr val="142A55"/>
+            </a:solidFill>
+          </a:ln>
+          <a:effectLst/>
+        </p:spPr>
+        <p:style>
+          <a:lnRef idx="1">
+            <a:schemeClr val="accent1"/>
+          </a:lnRef>
+          <a:fillRef idx="3">
+            <a:schemeClr val="accent1"/>
+          </a:fillRef>
+          <a:effectRef idx="2">
+            <a:schemeClr val="accent1"/>
+          </a:effectRef>
+          <a:fontRef idx="minor">
+            <a:schemeClr val="lt1"/>
+          </a:fontRef>
+        </p:style>
+        <p:txBody>
+          <a:bodyPr rtlCol="0" anchor="ctr"/>
+          <a:lstStyle/>
+          <a:p>
+            <a:pPr algn="ctr"/>
+          </a:p>
+        </p:txBody>
+      </p:sp>
+      <p:sp>
+        <p:nvSpPr>
+          <p:cNvPr id="26" name="TextBox 25"/>
+          <p:cNvSpPr txBox="1"/>
+          <p:nvPr/>
+        </p:nvSpPr>
+        <p:spPr>
+          <a:xfrm>
+            <a:off x="594360" y="3154680"/>
+            <a:ext cx="5257800" cy="411480"/>
+          </a:xfrm>
+          <a:prstGeom prst="rect">
+            <a:avLst/>
+          </a:prstGeom>
+          <a:noFill/>
+        </p:spPr>
+        <p:txBody>
+          <a:bodyPr wrap="none">
+            <a:spAutoFit/>
+          </a:bodyPr>
+          <a:lstStyle/>
+          <a:p>
+            <a:r>
+              <a:rPr sz="1600" b="1">
+                <a:solidFill>
+                  <a:srgbClr val="142A55"/>
+                </a:solidFill>
+                <a:latin typeface="Calibri"/>
+              </a:rPr>
+              <a:t>모델 간 데이터 흐름</a:t>
+            </a:r>
+          </a:p>
+        </p:txBody>
+      </p:sp>
+      <p:sp>
+        <p:nvSpPr>
+          <p:cNvPr id="27" name="TextBox 26"/>
+          <p:cNvSpPr txBox="1"/>
+          <p:nvPr/>
+        </p:nvSpPr>
+        <p:spPr>
+          <a:xfrm>
+            <a:off x="594360" y="3611880"/>
+            <a:ext cx="5257800" cy="2514600"/>
+          </a:xfrm>
+          <a:prstGeom prst="rect">
+            <a:avLst/>
+          </a:prstGeom>
+          <a:noFill/>
+        </p:spPr>
+        <p:txBody>
+          <a:bodyPr wrap="square">
+            <a:spAutoFit/>
+          </a:bodyPr>
+          <a:lstStyle/>
+          <a:p>
+            <a:pPr>
+              <a:spcAft>
+                <a:spcPts val="400"/>
+              </a:spcAft>
+            </a:pPr>
+            <a:r>
+              <a:rPr sz="1200" b="0">
+                <a:solidFill>
+                  <a:srgbClr val="222933"/>
+                </a:solidFill>
+                <a:latin typeface="Calibri"/>
+              </a:rPr>
+              <a:t>• UI-Venus 출력(bbox_1000) → 픽셀 bbox 환산 → crop box 계산 입력으로 전달</a:t>
+            </a:r>
+          </a:p>
+          <a:p>
+            <a:pPr>
+              <a:spcAft>
+                <a:spcPts val="400"/>
+              </a:spcAft>
+            </a:pPr>
+            <a:r>
+              <a:rPr sz="1200" b="0">
+                <a:solidFill>
+                  <a:srgbClr val="222933"/>
+                </a:solidFill>
+                <a:latin typeface="Calibri"/>
+              </a:rPr>
+              <a:t>• Crop 이미지 + 동일한 target description → MAI-UI 입력으로 전달 (역할 키 재사용)</a:t>
+            </a:r>
+          </a:p>
+          <a:p>
+            <a:pPr>
+              <a:spcAft>
+                <a:spcPts val="400"/>
+              </a:spcAft>
+            </a:pPr>
+            <a:r>
+              <a:rPr sz="1200" b="0">
+                <a:solidFill>
+                  <a:srgbClr val="222933"/>
+                </a:solidFill>
+                <a:latin typeface="Calibri"/>
+              </a:rPr>
+              <a:t>• MAI-UI 의 zoom 좌표 → crop 오프셋을 더해 원본 이미지 좌표계로 역변환</a:t>
+            </a:r>
+          </a:p>
+          <a:p>
+            <a:pPr>
+              <a:spcAft>
+                <a:spcPts val="400"/>
+              </a:spcAft>
+            </a:pPr>
+            <a:r>
+              <a:rPr sz="1200" b="0">
+                <a:solidFill>
+                  <a:srgbClr val="222933"/>
+                </a:solidFill>
+                <a:latin typeface="Calibri"/>
+              </a:rPr>
+              <a:t>• 원본 좌표계의 클릭 포인트 → pynput 으로 실제 클릭/키 입력 실행</a:t>
+            </a:r>
+          </a:p>
+          <a:p>
+            <a:pPr>
+              <a:spcAft>
+                <a:spcPts val="400"/>
+              </a:spcAft>
+            </a:pPr>
+            <a:r>
+              <a:rPr sz="1200" b="0">
+                <a:solidFill>
+                  <a:srgbClr val="222933"/>
+                </a:solidFill>
+                <a:latin typeface="Calibri"/>
+              </a:rPr>
+              <a:t>• 입력 후 캡처 → PaddleOCR-VL 로 텍스트 검증 → 다음 단계 진행 또는 재시도</a:t>
+            </a:r>
+          </a:p>
+        </p:txBody>
+      </p:sp>
+      <p:sp>
+        <p:nvSpPr>
+          <p:cNvPr id="28" name="Rounded Rectangle 27"/>
+          <p:cNvSpPr/>
+          <p:nvPr/>
+        </p:nvSpPr>
+        <p:spPr>
+          <a:xfrm>
+            <a:off x="6263640" y="3017520"/>
+            <a:ext cx="5577840" cy="3246120"/>
+          </a:xfrm>
+          <a:prstGeom prst="roundRect">
+            <a:avLst/>
+          </a:prstGeom>
+          <a:solidFill>
+            <a:srgbClr val="F4F6FA"/>
+          </a:solidFill>
+          <a:ln w="9525">
+            <a:solidFill>
+              <a:srgbClr val="142A55"/>
+            </a:solidFill>
+          </a:ln>
+          <a:effectLst/>
+        </p:spPr>
+        <p:style>
+          <a:lnRef idx="1">
+            <a:schemeClr val="accent1"/>
+          </a:lnRef>
+          <a:fillRef idx="3">
+            <a:schemeClr val="accent1"/>
+          </a:fillRef>
+          <a:effectRef idx="2">
+            <a:schemeClr val="accent1"/>
+          </a:effectRef>
+          <a:fontRef idx="minor">
+            <a:schemeClr val="lt1"/>
+          </a:fontRef>
+        </p:style>
+        <p:txBody>
+          <a:bodyPr rtlCol="0" anchor="ctr"/>
+          <a:lstStyle/>
+          <a:p>
+            <a:pPr algn="ctr"/>
+          </a:p>
+        </p:txBody>
+      </p:sp>
+      <p:sp>
+        <p:nvSpPr>
+          <p:cNvPr id="29" name="TextBox 28"/>
+          <p:cNvSpPr txBox="1"/>
+          <p:nvPr/>
+        </p:nvSpPr>
+        <p:spPr>
+          <a:xfrm>
+            <a:off x="6492240" y="3154680"/>
+            <a:ext cx="5120640" cy="411480"/>
+          </a:xfrm>
+          <a:prstGeom prst="rect">
+            <a:avLst/>
+          </a:prstGeom>
+          <a:noFill/>
+        </p:spPr>
+        <p:txBody>
+          <a:bodyPr wrap="none">
+            <a:spAutoFit/>
+          </a:bodyPr>
+          <a:lstStyle/>
+          <a:p>
+            <a:r>
+              <a:rPr sz="1600" b="1">
+                <a:solidFill>
+                  <a:srgbClr val="142A55"/>
+                </a:solidFill>
+                <a:latin typeface="Calibri"/>
+              </a:rPr>
+              <a:t>구현 위치 / 핵심 파일</a:t>
+            </a:r>
+          </a:p>
+        </p:txBody>
+      </p:sp>
+      <p:sp>
+        <p:nvSpPr>
+          <p:cNvPr id="30" name="TextBox 29"/>
+          <p:cNvSpPr txBox="1"/>
+          <p:nvPr/>
+        </p:nvSpPr>
+        <p:spPr>
+          <a:xfrm>
+            <a:off x="6492240" y="3611880"/>
+            <a:ext cx="5120640" cy="2514600"/>
+          </a:xfrm>
+          <a:prstGeom prst="rect">
+            <a:avLst/>
+          </a:prstGeom>
+          <a:noFill/>
+        </p:spPr>
+        <p:txBody>
+          <a:bodyPr wrap="square">
+            <a:spAutoFit/>
+          </a:bodyPr>
+          <a:lstStyle/>
+          <a:p>
+            <a:pPr>
+              <a:spcAft>
+                <a:spcPts val="400"/>
+              </a:spcAft>
+            </a:pPr>
+            <a:r>
+              <a:rPr sz="1200" b="0">
+                <a:solidFill>
+                  <a:srgbClr val="222933"/>
+                </a:solidFill>
+                <a:latin typeface="Calibri"/>
+              </a:rPr>
+              <a:t>• ui_venus_mai_locator.py — analyze_window_target() 가 2단계 파이프라인 오케스트레이션</a:t>
+            </a:r>
+          </a:p>
+          <a:p>
+            <a:pPr>
+              <a:spcAft>
+                <a:spcPts val="400"/>
+              </a:spcAft>
+            </a:pPr>
+            <a:r>
+              <a:rPr sz="1200" b="0">
+                <a:solidFill>
+                  <a:srgbClr val="222933"/>
+                </a:solidFill>
+                <a:latin typeface="Calibri"/>
+              </a:rPr>
+              <a:t>• _run_ui_venus_coarse_bbox() / _run_mai_ui_refinement() — 각 모델 호출 분리</a:t>
+            </a:r>
+          </a:p>
+          <a:p>
+            <a:pPr>
+              <a:spcAft>
+                <a:spcPts val="400"/>
+              </a:spcAft>
+            </a:pPr>
+            <a:r>
+              <a:rPr sz="1200" b="0">
+                <a:solidFill>
+                  <a:srgbClr val="222933"/>
+                </a:solidFill>
+                <a:latin typeface="Calibri"/>
+              </a:rPr>
+              <a:t>• _build_crop_box() — coarse bbox + padding 비율로 zoom 영역 산출</a:t>
+            </a:r>
+          </a:p>
+          <a:p>
+            <a:pPr>
+              <a:spcAft>
+                <a:spcPts val="400"/>
+              </a:spcAft>
+            </a:pPr>
+            <a:r>
+              <a:rPr sz="1200" b="0">
+                <a:solidFill>
+                  <a:srgbClr val="222933"/>
+                </a:solidFill>
+                <a:latin typeface="Calibri"/>
+              </a:rPr>
+              <a:t>• prompts/prompt_login_rcs_ui_venus.py / prompt_login_rcs_mai_ui.py — 모델별 프롬프트 분리</a:t>
+            </a:r>
+          </a:p>
+          <a:p>
+            <a:pPr>
+              <a:spcAft>
+                <a:spcPts val="400"/>
+              </a:spcAft>
+            </a:pPr>
+            <a:r>
+              <a:rPr sz="1200" b="0">
+                <a:solidFill>
+                  <a:srgbClr val="222933"/>
+                </a:solidFill>
+                <a:latin typeface="Calibri"/>
+              </a:rPr>
+              <a:t>• prompts/prompt_ocr_assist.py — PaddleOCR-VL 기반 텍스트 검증 프롬프트</a:t>
+            </a:r>
+          </a:p>
+          <a:p>
+            <a:pPr>
+              <a:spcAft>
+                <a:spcPts val="400"/>
+              </a:spcAft>
+            </a:pPr>
+            <a:r>
+              <a:rPr sz="1200" b="0">
+                <a:solidFill>
+                  <a:srgbClr val="222933"/>
+                </a:solidFill>
+                <a:latin typeface="Calibri"/>
+              </a:rPr>
+              <a:t>• flask_vlm.py — service slug 별로 ui-venus / mai-ui / paddleocr-vl-1.5 라우팅</a:t>
+            </a:r>
+          </a:p>
+        </p:txBody>
+      </p:sp>
+      <p:sp>
+        <p:nvSpPr>
+          <p:cNvPr id="31" name="TextBox 30"/>
+          <p:cNvSpPr txBox="1"/>
+          <p:nvPr/>
+        </p:nvSpPr>
+        <p:spPr>
+          <a:xfrm>
+            <a:off x="365760" y="6446520"/>
+            <a:ext cx="11430000" cy="274320"/>
+          </a:xfrm>
+          <a:prstGeom prst="rect">
+            <a:avLst/>
+          </a:prstGeom>
+          <a:noFill/>
+        </p:spPr>
+        <p:txBody>
+          <a:bodyPr wrap="none">
+            <a:spAutoFit/>
+          </a:bodyPr>
+          <a:lstStyle/>
+          <a:p>
+            <a:r>
+              <a:rPr sz="1000" b="0">
+                <a:solidFill>
+                  <a:srgbClr val="556070"/>
+                </a:solidFill>
+                <a:latin typeface="Calibri"/>
+              </a:rPr>
+              <a:t>Coarse Locator → Fine Refiner → Text Verifier  •  서로 다른 모델이 자기 강점만 책임진다</a:t>
+            </a:r>
+          </a:p>
+        </p:txBody>
+      </p:sp>
+    </p:spTree>
+  </p:cSld>
+  <p:clrMapOvr>
+    <a:masterClrMapping/>
+  </p:clrMapOvr>
+</p:sld>
+</file>
+
+<file path=ppt/slides/slide5.xml><?xml version="1.0" encoding="utf-8"?>
 <p:sld xmlns:a="http://schemas.openxmlformats.org/drawingml/2006/main" xmlns:p="http://schemas.openxmlformats.org/presentationml/2006/main" xmlns:r="http://schemas.openxmlformats.org/officeDocument/2006/relationships">
   <p:cSld>
     <p:spTree>

</xml_diff>